<commit_message>
Ajustar layout y caracteres de presentacion
</commit_message>
<xml_diff>
--- a/presentacion/PRESENTACION_MODELOS_FINAL.pptx
+++ b/presentacion/PRESENTACION_MODELOS_FINAL.pptx
@@ -3157,7 +3157,7 @@
         <p:spPr>
           <a:xfrm>
             <a:off x="731520" y="685800"/>
-            <a:ext cx="10789920" cy="457200"/>
+            <a:ext cx="10789920" cy="502920"/>
           </a:xfrm>
           <a:prstGeom prst="rect">
             <a:avLst/>
@@ -3165,20 +3165,20 @@
           <a:noFill/>
         </p:spPr>
         <p:txBody>
-          <a:bodyPr wrap="square">
+          <a:bodyPr wrap="square" anchor="t">
             <a:normAutofit/>
           </a:bodyPr>
           <a:lstStyle/>
           <a:p>
             <a:pPr algn="ctr"/>
             <a:r>
-              <a:rPr sz="3600" b="1">
+              <a:rPr sz="3400" b="1">
                 <a:solidFill>
                   <a:srgbClr val="FFFFFF"/>
                 </a:solidFill>
                 <a:latin typeface="Aptos"/>
               </a:rPr>
-              <a:t>Prediccion de popularidad musical</a:t>
+              <a:t>Predicción de popularidad musical</a:t>
             </a:r>
           </a:p>
         </p:txBody>
@@ -3191,8 +3191,8 @@
         </p:nvSpPr>
         <p:spPr>
           <a:xfrm>
-            <a:off x="1143000" y="1417320"/>
-            <a:ext cx="9875520" cy="457200"/>
+            <a:off x="1097280" y="1325880"/>
+            <a:ext cx="9966960" cy="411480"/>
           </a:xfrm>
           <a:prstGeom prst="rect">
             <a:avLst/>
@@ -3200,20 +3200,20 @@
           <a:noFill/>
         </p:spPr>
         <p:txBody>
-          <a:bodyPr wrap="square">
+          <a:bodyPr wrap="square" anchor="t">
             <a:normAutofit/>
           </a:bodyPr>
           <a:lstStyle/>
           <a:p>
             <a:pPr algn="ctr"/>
             <a:r>
-              <a:rPr sz="2200" b="0">
-                <a:solidFill>
-                  <a:srgbClr val="D2E1FA"/>
+              <a:rPr sz="2100" b="0">
+                <a:solidFill>
+                  <a:srgbClr val="D6E5FA"/>
                 </a:solidFill>
                 <a:latin typeface="Aptos"/>
               </a:rPr>
-              <a:t>Modelado, seleccion y resultados finales</a:t>
+              <a:t>Modelado, selección y resultados finales</a:t>
             </a:r>
           </a:p>
         </p:txBody>
@@ -3226,8 +3226,8 @@
         </p:nvSpPr>
         <p:spPr>
           <a:xfrm>
-            <a:off x="1097280" y="2788920"/>
-            <a:ext cx="2926080" cy="1417320"/>
+            <a:off x="1005840" y="2788920"/>
+            <a:ext cx="2971800" cy="1325880"/>
           </a:xfrm>
           <a:prstGeom prst="roundRect">
             <a:avLst/>
@@ -3271,8 +3271,8 @@
         </p:nvSpPr>
         <p:spPr>
           <a:xfrm>
-            <a:off x="1261872" y="2916936"/>
-            <a:ext cx="2596896" cy="256032"/>
+            <a:off x="1143000" y="2898648"/>
+            <a:ext cx="2697480" cy="228600"/>
           </a:xfrm>
           <a:prstGeom prst="rect">
             <a:avLst/>
@@ -3280,14 +3280,14 @@
           <a:noFill/>
         </p:spPr>
         <p:txBody>
-          <a:bodyPr wrap="square">
+          <a:bodyPr wrap="square" anchor="t">
             <a:normAutofit/>
           </a:bodyPr>
           <a:lstStyle/>
           <a:p>
             <a:pPr algn="l"/>
             <a:r>
-              <a:rPr sz="1200" b="1">
+              <a:rPr sz="1100" b="1">
                 <a:solidFill>
                   <a:srgbClr val="647082"/>
                 </a:solidFill>
@@ -3306,8 +3306,8 @@
         </p:nvSpPr>
         <p:spPr>
           <a:xfrm>
-            <a:off x="1261872" y="3227832"/>
-            <a:ext cx="2596896" cy="502920"/>
+            <a:off x="1143000" y="3182112"/>
+            <a:ext cx="2697480" cy="411480"/>
           </a:xfrm>
           <a:prstGeom prst="rect">
             <a:avLst/>
@@ -3315,14 +3315,14 @@
           <a:noFill/>
         </p:spPr>
         <p:txBody>
-          <a:bodyPr wrap="square">
+          <a:bodyPr wrap="square" anchor="t">
             <a:normAutofit/>
           </a:bodyPr>
           <a:lstStyle/>
           <a:p>
             <a:pPr algn="l"/>
             <a:r>
-              <a:rPr sz="2400" b="1">
+              <a:rPr sz="2200" b="1">
                 <a:solidFill>
                   <a:srgbClr val="28A745"/>
                 </a:solidFill>
@@ -3341,8 +3341,8 @@
         </p:nvSpPr>
         <p:spPr>
           <a:xfrm>
-            <a:off x="1261872" y="3776472"/>
-            <a:ext cx="2596896" cy="320040"/>
+            <a:off x="1143000" y="3630168"/>
+            <a:ext cx="2697480" cy="228600"/>
           </a:xfrm>
           <a:prstGeom prst="rect">
             <a:avLst/>
@@ -3350,20 +3350,20 @@
           <a:noFill/>
         </p:spPr>
         <p:txBody>
-          <a:bodyPr wrap="square">
+          <a:bodyPr wrap="square" anchor="t">
             <a:normAutofit/>
           </a:bodyPr>
           <a:lstStyle/>
           <a:p>
             <a:pPr algn="l"/>
             <a:r>
-              <a:rPr sz="1000" b="0">
+              <a:rPr sz="950" b="0">
                 <a:solidFill>
                   <a:srgbClr val="647082"/>
                 </a:solidFill>
                 <a:latin typeface="Aptos"/>
               </a:rPr>
-              <a:t>R2 publico</a:t>
+              <a:t>R2 público</a:t>
             </a:r>
           </a:p>
         </p:txBody>
@@ -3377,7 +3377,7 @@
         <p:spPr>
           <a:xfrm>
             <a:off x="4617720" y="2788920"/>
-            <a:ext cx="2926080" cy="1417320"/>
+            <a:ext cx="2971800" cy="1325880"/>
           </a:xfrm>
           <a:prstGeom prst="roundRect">
             <a:avLst/>
@@ -3421,8 +3421,8 @@
         </p:nvSpPr>
         <p:spPr>
           <a:xfrm>
-            <a:off x="4782312" y="2916936"/>
-            <a:ext cx="2596896" cy="256032"/>
+            <a:off x="4754880" y="2898648"/>
+            <a:ext cx="2697480" cy="228600"/>
           </a:xfrm>
           <a:prstGeom prst="rect">
             <a:avLst/>
@@ -3430,14 +3430,14 @@
           <a:noFill/>
         </p:spPr>
         <p:txBody>
-          <a:bodyPr wrap="square">
+          <a:bodyPr wrap="square" anchor="t">
             <a:normAutofit/>
           </a:bodyPr>
           <a:lstStyle/>
           <a:p>
             <a:pPr algn="l"/>
             <a:r>
-              <a:rPr sz="1200" b="1">
+              <a:rPr sz="1100" b="1">
                 <a:solidFill>
                   <a:srgbClr val="647082"/>
                 </a:solidFill>
@@ -3456,8 +3456,8 @@
         </p:nvSpPr>
         <p:spPr>
           <a:xfrm>
-            <a:off x="4782312" y="3227832"/>
-            <a:ext cx="2596896" cy="502920"/>
+            <a:off x="4754880" y="3182112"/>
+            <a:ext cx="2697480" cy="411480"/>
           </a:xfrm>
           <a:prstGeom prst="rect">
             <a:avLst/>
@@ -3465,14 +3465,14 @@
           <a:noFill/>
         </p:spPr>
         <p:txBody>
-          <a:bodyPr wrap="square">
+          <a:bodyPr wrap="square" anchor="t">
             <a:normAutofit/>
           </a:bodyPr>
           <a:lstStyle/>
           <a:p>
             <a:pPr algn="l"/>
             <a:r>
-              <a:rPr sz="2400" b="1">
+              <a:rPr sz="2200" b="1">
                 <a:solidFill>
                   <a:srgbClr val="40B7DA"/>
                 </a:solidFill>
@@ -3491,8 +3491,8 @@
         </p:nvSpPr>
         <p:spPr>
           <a:xfrm>
-            <a:off x="4782312" y="3776472"/>
-            <a:ext cx="2596896" cy="320040"/>
+            <a:off x="4754880" y="3630168"/>
+            <a:ext cx="2697480" cy="228600"/>
           </a:xfrm>
           <a:prstGeom prst="rect">
             <a:avLst/>
@@ -3500,20 +3500,20 @@
           <a:noFill/>
         </p:spPr>
         <p:txBody>
-          <a:bodyPr wrap="square">
+          <a:bodyPr wrap="square" anchor="t">
             <a:normAutofit/>
           </a:bodyPr>
           <a:lstStyle/>
           <a:p>
             <a:pPr algn="l"/>
             <a:r>
-              <a:rPr sz="1000" b="0">
+              <a:rPr sz="950" b="0">
                 <a:solidFill>
                   <a:srgbClr val="647082"/>
                 </a:solidFill>
                 <a:latin typeface="Aptos"/>
               </a:rPr>
-              <a:t>R2 publico</a:t>
+              <a:t>R2 público</a:t>
             </a:r>
           </a:p>
         </p:txBody>
@@ -3526,8 +3526,8 @@
         </p:nvSpPr>
         <p:spPr>
           <a:xfrm>
-            <a:off x="8138160" y="2788920"/>
-            <a:ext cx="2926080" cy="1417320"/>
+            <a:off x="8183879" y="2788920"/>
+            <a:ext cx="2971800" cy="1325880"/>
           </a:xfrm>
           <a:prstGeom prst="roundRect">
             <a:avLst/>
@@ -3571,8 +3571,8 @@
         </p:nvSpPr>
         <p:spPr>
           <a:xfrm>
-            <a:off x="8302752" y="2916936"/>
-            <a:ext cx="2596896" cy="256032"/>
+            <a:off x="8321040" y="2898648"/>
+            <a:ext cx="2697480" cy="228600"/>
           </a:xfrm>
           <a:prstGeom prst="rect">
             <a:avLst/>
@@ -3580,14 +3580,14 @@
           <a:noFill/>
         </p:spPr>
         <p:txBody>
-          <a:bodyPr wrap="square">
+          <a:bodyPr wrap="square" anchor="t">
             <a:normAutofit/>
           </a:bodyPr>
           <a:lstStyle/>
           <a:p>
             <a:pPr algn="l"/>
             <a:r>
-              <a:rPr sz="1200" b="1">
+              <a:rPr sz="1100" b="1">
                 <a:solidFill>
                   <a:srgbClr val="647082"/>
                 </a:solidFill>
@@ -3606,8 +3606,8 @@
         </p:nvSpPr>
         <p:spPr>
           <a:xfrm>
-            <a:off x="8302752" y="3227832"/>
-            <a:ext cx="2596896" cy="502920"/>
+            <a:off x="8321040" y="3182112"/>
+            <a:ext cx="2697480" cy="411480"/>
           </a:xfrm>
           <a:prstGeom prst="rect">
             <a:avLst/>
@@ -3615,14 +3615,14 @@
           <a:noFill/>
         </p:spPr>
         <p:txBody>
-          <a:bodyPr wrap="square">
+          <a:bodyPr wrap="square" anchor="t">
             <a:normAutofit/>
           </a:bodyPr>
           <a:lstStyle/>
           <a:p>
             <a:pPr algn="l"/>
             <a:r>
-              <a:rPr sz="2400" b="1">
+              <a:rPr sz="2200" b="1">
                 <a:solidFill>
                   <a:srgbClr val="FF9F40"/>
                 </a:solidFill>
@@ -3641,8 +3641,8 @@
         </p:nvSpPr>
         <p:spPr>
           <a:xfrm>
-            <a:off x="8302752" y="3776472"/>
-            <a:ext cx="2596896" cy="320040"/>
+            <a:off x="8321040" y="3630168"/>
+            <a:ext cx="2697480" cy="228600"/>
           </a:xfrm>
           <a:prstGeom prst="rect">
             <a:avLst/>
@@ -3650,20 +3650,20 @@
           <a:noFill/>
         </p:spPr>
         <p:txBody>
-          <a:bodyPr wrap="square">
+          <a:bodyPr wrap="square" anchor="t">
             <a:normAutofit/>
           </a:bodyPr>
           <a:lstStyle/>
           <a:p>
             <a:pPr algn="l"/>
             <a:r>
-              <a:rPr sz="1000" b="0">
+              <a:rPr sz="950" b="0">
                 <a:solidFill>
                   <a:srgbClr val="647082"/>
                 </a:solidFill>
                 <a:latin typeface="Aptos"/>
               </a:rPr>
-              <a:t>Optimizacion leaderboard</a:t>
+              <a:t>Optimización leaderboard</a:t>
             </a:r>
           </a:p>
         </p:txBody>
@@ -3676,8 +3676,8 @@
         </p:nvSpPr>
         <p:spPr>
           <a:xfrm>
-            <a:off x="1005840" y="5897880"/>
-            <a:ext cx="10241280" cy="320040"/>
+            <a:off x="1097280" y="5806440"/>
+            <a:ext cx="10012680" cy="411480"/>
           </a:xfrm>
           <a:prstGeom prst="rect">
             <a:avLst/>
@@ -3685,20 +3685,20 @@
           <a:noFill/>
         </p:spPr>
         <p:txBody>
-          <a:bodyPr wrap="square">
+          <a:bodyPr wrap="square" anchor="t">
             <a:normAutofit/>
           </a:bodyPr>
           <a:lstStyle/>
           <a:p>
             <a:pPr algn="ctr"/>
             <a:r>
-              <a:rPr sz="1400" b="0">
+              <a:rPr sz="1500" b="0">
                 <a:solidFill>
                   <a:srgbClr val="DCE6F5"/>
                 </a:solidFill>
                 <a:latin typeface="Aptos"/>
               </a:rPr>
-              <a:t>Entrega: pipeline predictivo reproducible + experimento adicional de competencia</a:t>
+              <a:t>Entrega principal: pipeline reproducible. Resultado adicional: optimización competitiva.</a:t>
             </a:r>
           </a:p>
         </p:txBody>
@@ -3738,7 +3738,7 @@
         <p:spPr>
           <a:xfrm>
             <a:off x="0" y="0"/>
-            <a:ext cx="12191695" cy="658368"/>
+            <a:ext cx="12191695" cy="621792"/>
           </a:xfrm>
           <a:prstGeom prst="rect">
             <a:avLst/>
@@ -3780,8 +3780,8 @@
         </p:nvSpPr>
         <p:spPr>
           <a:xfrm>
-            <a:off x="411480" y="118872"/>
-            <a:ext cx="10789920" cy="411480"/>
+            <a:off x="411480" y="109728"/>
+            <a:ext cx="11064240" cy="384048"/>
           </a:xfrm>
           <a:prstGeom prst="rect">
             <a:avLst/>
@@ -3789,14 +3789,14 @@
           <a:noFill/>
         </p:spPr>
         <p:txBody>
-          <a:bodyPr wrap="square">
+          <a:bodyPr wrap="square" anchor="t">
             <a:normAutofit/>
           </a:bodyPr>
           <a:lstStyle/>
           <a:p>
             <a:pPr algn="l"/>
             <a:r>
-              <a:rPr sz="2300" b="1">
+              <a:rPr sz="2200" b="1">
                 <a:solidFill>
                   <a:srgbClr val="FFFFFF"/>
                 </a:solidFill>
@@ -3816,7 +3816,7 @@
         <p:spPr>
           <a:xfrm>
             <a:off x="731520" y="914400"/>
-            <a:ext cx="10972800" cy="502920"/>
+            <a:ext cx="10972800" cy="411480"/>
           </a:xfrm>
           <a:prstGeom prst="rect">
             <a:avLst/>
@@ -3824,20 +3824,20 @@
           <a:noFill/>
         </p:spPr>
         <p:txBody>
-          <a:bodyPr wrap="square">
+          <a:bodyPr wrap="square" anchor="t">
             <a:normAutofit/>
           </a:bodyPr>
           <a:lstStyle/>
           <a:p>
             <a:pPr algn="ctr"/>
             <a:r>
-              <a:rPr sz="3000" b="1">
+              <a:rPr sz="2900" b="1">
                 <a:solidFill>
                   <a:srgbClr val="0A1F44"/>
                 </a:solidFill>
                 <a:latin typeface="Aptos"/>
               </a:rPr>
-              <a:t>Conclusion</a:t>
+              <a:t>Conclusión</a:t>
             </a:r>
           </a:p>
         </p:txBody>
@@ -3850,8 +3850,8 @@
         </p:nvSpPr>
         <p:spPr>
           <a:xfrm>
-            <a:off x="960120" y="1691640"/>
-            <a:ext cx="10287000" cy="1005840"/>
+            <a:off x="1051560" y="1600200"/>
+            <a:ext cx="10104120" cy="868680"/>
           </a:xfrm>
           <a:prstGeom prst="rect">
             <a:avLst/>
@@ -3859,20 +3859,20 @@
           <a:noFill/>
         </p:spPr>
         <p:txBody>
-          <a:bodyPr wrap="square">
+          <a:bodyPr wrap="square" anchor="t">
             <a:normAutofit/>
           </a:bodyPr>
           <a:lstStyle/>
           <a:p>
             <a:pPr algn="ctr"/>
             <a:r>
-              <a:rPr sz="2400" b="0">
+              <a:rPr sz="2300" b="0">
                 <a:solidFill>
                   <a:srgbClr val="232D3C"/>
                 </a:solidFill>
                 <a:latin typeface="Aptos"/>
               </a:rPr>
-              <a:t>El trabajo mostro que el problema no era solamente entrenar un modelo con buena CV, sino adaptarse a un test con distribucion distinta.</a:t>
+              <a:t>El desafío no fue solo entrenar un modelo con buena CV, sino adaptarse a un test con distribución distinta.</a:t>
             </a:r>
           </a:p>
         </p:txBody>
@@ -3885,7 +3885,7 @@
         </p:nvSpPr>
         <p:spPr>
           <a:xfrm>
-            <a:off x="1005840" y="3246120"/>
+            <a:off x="1005840" y="3108960"/>
             <a:ext cx="3017520" cy="1234440"/>
           </a:xfrm>
           <a:prstGeom prst="roundRect">
@@ -3930,8 +3930,8 @@
         </p:nvSpPr>
         <p:spPr>
           <a:xfrm>
-            <a:off x="1170432" y="3374136"/>
-            <a:ext cx="2688336" cy="256032"/>
+            <a:off x="1143000" y="3218688"/>
+            <a:ext cx="2743200" cy="228600"/>
           </a:xfrm>
           <a:prstGeom prst="rect">
             <a:avLst/>
@@ -3939,14 +3939,14 @@
           <a:noFill/>
         </p:spPr>
         <p:txBody>
-          <a:bodyPr wrap="square">
+          <a:bodyPr wrap="square" anchor="t">
             <a:normAutofit/>
           </a:bodyPr>
           <a:lstStyle/>
           <a:p>
             <a:pPr algn="l"/>
             <a:r>
-              <a:rPr sz="1200" b="1">
+              <a:rPr sz="1100" b="1">
                 <a:solidFill>
                   <a:srgbClr val="647082"/>
                 </a:solidFill>
@@ -3965,8 +3965,8 @@
         </p:nvSpPr>
         <p:spPr>
           <a:xfrm>
-            <a:off x="1170432" y="3685031"/>
-            <a:ext cx="2688336" cy="502920"/>
+            <a:off x="1143000" y="3502152"/>
+            <a:ext cx="2743200" cy="411480"/>
           </a:xfrm>
           <a:prstGeom prst="rect">
             <a:avLst/>
@@ -3974,14 +3974,14 @@
           <a:noFill/>
         </p:spPr>
         <p:txBody>
-          <a:bodyPr wrap="square">
+          <a:bodyPr wrap="square" anchor="t">
             <a:normAutofit/>
           </a:bodyPr>
           <a:lstStyle/>
           <a:p>
             <a:pPr algn="l"/>
             <a:r>
-              <a:rPr sz="2400" b="1">
+              <a:rPr sz="2200" b="1">
                 <a:solidFill>
                   <a:srgbClr val="40B7DA"/>
                 </a:solidFill>
@@ -4000,8 +4000,8 @@
         </p:nvSpPr>
         <p:spPr>
           <a:xfrm>
-            <a:off x="1170432" y="4233672"/>
-            <a:ext cx="2688336" cy="320040"/>
+            <a:off x="1143000" y="3950208"/>
+            <a:ext cx="2743200" cy="228600"/>
           </a:xfrm>
           <a:prstGeom prst="rect">
             <a:avLst/>
@@ -4009,14 +4009,14 @@
           <a:noFill/>
         </p:spPr>
         <p:txBody>
-          <a:bodyPr wrap="square">
+          <a:bodyPr wrap="square" anchor="t">
             <a:normAutofit/>
           </a:bodyPr>
           <a:lstStyle/>
           <a:p>
             <a:pPr algn="l"/>
             <a:r>
-              <a:rPr sz="1000" b="0">
+              <a:rPr sz="950" b="0">
                 <a:solidFill>
                   <a:srgbClr val="647082"/>
                 </a:solidFill>
@@ -4035,7 +4035,7 @@
         </p:nvSpPr>
         <p:spPr>
           <a:xfrm>
-            <a:off x="4572000" y="3246120"/>
+            <a:off x="4572000" y="3108960"/>
             <a:ext cx="3017520" cy="1234440"/>
           </a:xfrm>
           <a:prstGeom prst="roundRect">
@@ -4080,8 +4080,8 @@
         </p:nvSpPr>
         <p:spPr>
           <a:xfrm>
-            <a:off x="4736592" y="3374136"/>
-            <a:ext cx="2688336" cy="256032"/>
+            <a:off x="4709160" y="3218688"/>
+            <a:ext cx="2743200" cy="228600"/>
           </a:xfrm>
           <a:prstGeom prst="rect">
             <a:avLst/>
@@ -4089,14 +4089,14 @@
           <a:noFill/>
         </p:spPr>
         <p:txBody>
-          <a:bodyPr wrap="square">
+          <a:bodyPr wrap="square" anchor="t">
             <a:normAutofit/>
           </a:bodyPr>
           <a:lstStyle/>
           <a:p>
             <a:pPr algn="l"/>
             <a:r>
-              <a:rPr sz="1200" b="1">
+              <a:rPr sz="1100" b="1">
                 <a:solidFill>
                   <a:srgbClr val="647082"/>
                 </a:solidFill>
@@ -4115,8 +4115,8 @@
         </p:nvSpPr>
         <p:spPr>
           <a:xfrm>
-            <a:off x="4736592" y="3685031"/>
-            <a:ext cx="2688336" cy="502920"/>
+            <a:off x="4709160" y="3502152"/>
+            <a:ext cx="2743200" cy="411480"/>
           </a:xfrm>
           <a:prstGeom prst="rect">
             <a:avLst/>
@@ -4124,14 +4124,14 @@
           <a:noFill/>
         </p:spPr>
         <p:txBody>
-          <a:bodyPr wrap="square">
+          <a:bodyPr wrap="square" anchor="t">
             <a:normAutofit/>
           </a:bodyPr>
           <a:lstStyle/>
           <a:p>
             <a:pPr algn="l"/>
             <a:r>
-              <a:rPr sz="2400" b="1">
+              <a:rPr sz="2200" b="1">
                 <a:solidFill>
                   <a:srgbClr val="28A745"/>
                 </a:solidFill>
@@ -4150,8 +4150,8 @@
         </p:nvSpPr>
         <p:spPr>
           <a:xfrm>
-            <a:off x="4736592" y="4233672"/>
-            <a:ext cx="2688336" cy="320040"/>
+            <a:off x="4709160" y="3950208"/>
+            <a:ext cx="2743200" cy="228600"/>
           </a:xfrm>
           <a:prstGeom prst="rect">
             <a:avLst/>
@@ -4159,14 +4159,14 @@
           <a:noFill/>
         </p:spPr>
         <p:txBody>
-          <a:bodyPr wrap="square">
+          <a:bodyPr wrap="square" anchor="t">
             <a:normAutofit/>
           </a:bodyPr>
           <a:lstStyle/>
           <a:p>
             <a:pPr algn="l"/>
             <a:r>
-              <a:rPr sz="1000" b="0">
+              <a:rPr sz="950" b="0">
                 <a:solidFill>
                   <a:srgbClr val="647082"/>
                 </a:solidFill>
@@ -4185,7 +4185,7 @@
         </p:nvSpPr>
         <p:spPr>
           <a:xfrm>
-            <a:off x="8138160" y="3246120"/>
+            <a:off x="8138160" y="3108960"/>
             <a:ext cx="3017520" cy="1234440"/>
           </a:xfrm>
           <a:prstGeom prst="roundRect">
@@ -4230,8 +4230,8 @@
         </p:nvSpPr>
         <p:spPr>
           <a:xfrm>
-            <a:off x="8302752" y="3374136"/>
-            <a:ext cx="2688336" cy="256032"/>
+            <a:off x="8275320" y="3218688"/>
+            <a:ext cx="2743200" cy="228600"/>
           </a:xfrm>
           <a:prstGeom prst="rect">
             <a:avLst/>
@@ -4239,14 +4239,14 @@
           <a:noFill/>
         </p:spPr>
         <p:txBody>
-          <a:bodyPr wrap="square">
+          <a:bodyPr wrap="square" anchor="t">
             <a:normAutofit/>
           </a:bodyPr>
           <a:lstStyle/>
           <a:p>
             <a:pPr algn="l"/>
             <a:r>
-              <a:rPr sz="1200" b="1">
+              <a:rPr sz="1100" b="1">
                 <a:solidFill>
                   <a:srgbClr val="647082"/>
                 </a:solidFill>
@@ -4265,8 +4265,8 @@
         </p:nvSpPr>
         <p:spPr>
           <a:xfrm>
-            <a:off x="8302752" y="3685031"/>
-            <a:ext cx="2688336" cy="502920"/>
+            <a:off x="8275320" y="3502152"/>
+            <a:ext cx="2743200" cy="411480"/>
           </a:xfrm>
           <a:prstGeom prst="rect">
             <a:avLst/>
@@ -4274,14 +4274,14 @@
           <a:noFill/>
         </p:spPr>
         <p:txBody>
-          <a:bodyPr wrap="square">
+          <a:bodyPr wrap="square" anchor="t">
             <a:normAutofit/>
           </a:bodyPr>
           <a:lstStyle/>
           <a:p>
             <a:pPr algn="l"/>
             <a:r>
-              <a:rPr sz="2400" b="1">
+              <a:rPr sz="2200" b="1">
                 <a:solidFill>
                   <a:srgbClr val="FF9F40"/>
                 </a:solidFill>
@@ -4300,8 +4300,8 @@
         </p:nvSpPr>
         <p:spPr>
           <a:xfrm>
-            <a:off x="8302752" y="4233672"/>
-            <a:ext cx="2688336" cy="320040"/>
+            <a:off x="8275320" y="3950208"/>
+            <a:ext cx="2743200" cy="228600"/>
           </a:xfrm>
           <a:prstGeom prst="rect">
             <a:avLst/>
@@ -4309,14 +4309,14 @@
           <a:noFill/>
         </p:spPr>
         <p:txBody>
-          <a:bodyPr wrap="square">
+          <a:bodyPr wrap="square" anchor="t">
             <a:normAutofit/>
           </a:bodyPr>
           <a:lstStyle/>
           <a:p>
             <a:pPr algn="l"/>
             <a:r>
-              <a:rPr sz="1000" b="0">
+              <a:rPr sz="950" b="0">
                 <a:solidFill>
                   <a:srgbClr val="647082"/>
                 </a:solidFill>
@@ -4335,7 +4335,7 @@
         </p:nvSpPr>
         <p:spPr>
           <a:xfrm>
-            <a:off x="914400" y="5715000"/>
+            <a:off x="914400" y="5669280"/>
             <a:ext cx="10424160" cy="502920"/>
           </a:xfrm>
           <a:prstGeom prst="rect">
@@ -4344,20 +4344,20 @@
           <a:noFill/>
         </p:spPr>
         <p:txBody>
-          <a:bodyPr wrap="square">
+          <a:bodyPr wrap="square" anchor="t">
             <a:normAutofit/>
           </a:bodyPr>
           <a:lstStyle/>
           <a:p>
             <a:pPr algn="ctr"/>
             <a:r>
-              <a:rPr sz="1700" b="1">
+              <a:rPr sz="1600" b="1">
                 <a:solidFill>
                   <a:srgbClr val="232D3C"/>
                 </a:solidFill>
                 <a:latin typeface="Aptos"/>
               </a:rPr>
-              <a:t>La entrega principal prioriza reproducibilidad y defensa metodologica; el mejor score se informa como exploracion adicional.</a:t>
+              <a:t>La entrega principal prioriza reproducibilidad y defensa metodológica; el mejor score se informa como exploración adicional.</a:t>
             </a:r>
           </a:p>
         </p:txBody>
@@ -4397,7 +4397,7 @@
         <p:spPr>
           <a:xfrm>
             <a:off x="0" y="0"/>
-            <a:ext cx="12191695" cy="658368"/>
+            <a:ext cx="12191695" cy="621792"/>
           </a:xfrm>
           <a:prstGeom prst="rect">
             <a:avLst/>
@@ -4439,8 +4439,8 @@
         </p:nvSpPr>
         <p:spPr>
           <a:xfrm>
-            <a:off x="411480" y="118872"/>
-            <a:ext cx="10789920" cy="411480"/>
+            <a:off x="411480" y="109728"/>
+            <a:ext cx="11064240" cy="384048"/>
           </a:xfrm>
           <a:prstGeom prst="rect">
             <a:avLst/>
@@ -4448,14 +4448,14 @@
           <a:noFill/>
         </p:spPr>
         <p:txBody>
-          <a:bodyPr wrap="square">
+          <a:bodyPr wrap="square" anchor="t">
             <a:normAutofit/>
           </a:bodyPr>
           <a:lstStyle/>
           <a:p>
             <a:pPr algn="l"/>
             <a:r>
-              <a:rPr sz="2300" b="1">
+              <a:rPr sz="2200" b="1">
                 <a:solidFill>
                   <a:srgbClr val="FFFFFF"/>
                 </a:solidFill>
@@ -4474,8 +4474,8 @@
         </p:nvSpPr>
         <p:spPr>
           <a:xfrm>
-            <a:off x="640080" y="960120"/>
-            <a:ext cx="2286000" cy="1143000"/>
+            <a:off x="594360" y="868680"/>
+            <a:ext cx="2331720" cy="1005840"/>
           </a:xfrm>
           <a:prstGeom prst="roundRect">
             <a:avLst/>
@@ -4519,8 +4519,8 @@
         </p:nvSpPr>
         <p:spPr>
           <a:xfrm>
-            <a:off x="804671" y="1088136"/>
-            <a:ext cx="1956816" cy="256032"/>
+            <a:off x="731520" y="978407"/>
+            <a:ext cx="2057400" cy="228600"/>
           </a:xfrm>
           <a:prstGeom prst="rect">
             <a:avLst/>
@@ -4528,14 +4528,14 @@
           <a:noFill/>
         </p:spPr>
         <p:txBody>
-          <a:bodyPr wrap="square">
+          <a:bodyPr wrap="square" anchor="t">
             <a:normAutofit/>
           </a:bodyPr>
           <a:lstStyle/>
           <a:p>
             <a:pPr algn="l"/>
             <a:r>
-              <a:rPr sz="1200" b="1">
+              <a:rPr sz="1100" b="1">
                 <a:solidFill>
                   <a:srgbClr val="647082"/>
                 </a:solidFill>
@@ -4554,8 +4554,8 @@
         </p:nvSpPr>
         <p:spPr>
           <a:xfrm>
-            <a:off x="804671" y="1399032"/>
-            <a:ext cx="1956816" cy="502920"/>
+            <a:off x="731520" y="1261872"/>
+            <a:ext cx="2057400" cy="411480"/>
           </a:xfrm>
           <a:prstGeom prst="rect">
             <a:avLst/>
@@ -4563,20 +4563,20 @@
           <a:noFill/>
         </p:spPr>
         <p:txBody>
-          <a:bodyPr wrap="square">
+          <a:bodyPr wrap="square" anchor="t">
             <a:normAutofit/>
           </a:bodyPr>
           <a:lstStyle/>
           <a:p>
             <a:pPr algn="l"/>
             <a:r>
-              <a:rPr sz="2400" b="1">
+              <a:rPr sz="2200" b="1">
                 <a:solidFill>
                   <a:srgbClr val="2462BF"/>
                 </a:solidFill>
                 <a:latin typeface="Aptos"/>
               </a:rPr>
-              <a:t>Regresion</a:t>
+              <a:t>Regresión</a:t>
             </a:r>
           </a:p>
         </p:txBody>
@@ -4589,8 +4589,8 @@
         </p:nvSpPr>
         <p:spPr>
           <a:xfrm>
-            <a:off x="804671" y="1947672"/>
-            <a:ext cx="1956816" cy="320040"/>
+            <a:off x="731520" y="1709928"/>
+            <a:ext cx="2057400" cy="228600"/>
           </a:xfrm>
           <a:prstGeom prst="rect">
             <a:avLst/>
@@ -4598,14 +4598,14 @@
           <a:noFill/>
         </p:spPr>
         <p:txBody>
-          <a:bodyPr wrap="square">
+          <a:bodyPr wrap="square" anchor="t">
             <a:normAutofit/>
           </a:bodyPr>
           <a:lstStyle/>
           <a:p>
             <a:pPr algn="l"/>
             <a:r>
-              <a:rPr sz="1000" b="0">
+              <a:rPr sz="950" b="0">
                 <a:solidFill>
                   <a:srgbClr val="647082"/>
                 </a:solidFill>
@@ -4624,8 +4624,8 @@
         </p:nvSpPr>
         <p:spPr>
           <a:xfrm>
-            <a:off x="3246120" y="960120"/>
-            <a:ext cx="2286000" cy="1143000"/>
+            <a:off x="3246120" y="868680"/>
+            <a:ext cx="2331720" cy="1005840"/>
           </a:xfrm>
           <a:prstGeom prst="roundRect">
             <a:avLst/>
@@ -4669,8 +4669,8 @@
         </p:nvSpPr>
         <p:spPr>
           <a:xfrm>
-            <a:off x="3410712" y="1088136"/>
-            <a:ext cx="1956816" cy="256032"/>
+            <a:off x="3383279" y="978407"/>
+            <a:ext cx="2057400" cy="228600"/>
           </a:xfrm>
           <a:prstGeom prst="rect">
             <a:avLst/>
@@ -4678,14 +4678,14 @@
           <a:noFill/>
         </p:spPr>
         <p:txBody>
-          <a:bodyPr wrap="square">
+          <a:bodyPr wrap="square" anchor="t">
             <a:normAutofit/>
           </a:bodyPr>
           <a:lstStyle/>
           <a:p>
             <a:pPr algn="l"/>
             <a:r>
-              <a:rPr sz="1200" b="1">
+              <a:rPr sz="1100" b="1">
                 <a:solidFill>
                   <a:srgbClr val="647082"/>
                 </a:solidFill>
@@ -4704,8 +4704,8 @@
         </p:nvSpPr>
         <p:spPr>
           <a:xfrm>
-            <a:off x="3410712" y="1399032"/>
-            <a:ext cx="1956816" cy="502920"/>
+            <a:off x="3383279" y="1261872"/>
+            <a:ext cx="2057400" cy="411480"/>
           </a:xfrm>
           <a:prstGeom prst="rect">
             <a:avLst/>
@@ -4713,14 +4713,14 @@
           <a:noFill/>
         </p:spPr>
         <p:txBody>
-          <a:bodyPr wrap="square">
+          <a:bodyPr wrap="square" anchor="t">
             <a:normAutofit/>
           </a:bodyPr>
           <a:lstStyle/>
           <a:p>
             <a:pPr algn="l"/>
             <a:r>
-              <a:rPr sz="2400" b="1">
+              <a:rPr sz="2200" b="1">
                 <a:solidFill>
                   <a:srgbClr val="2462BF"/>
                 </a:solidFill>
@@ -4739,8 +4739,8 @@
         </p:nvSpPr>
         <p:spPr>
           <a:xfrm>
-            <a:off x="3410712" y="1947672"/>
-            <a:ext cx="1956816" cy="320040"/>
+            <a:off x="3383279" y="1709928"/>
+            <a:ext cx="2057400" cy="228600"/>
           </a:xfrm>
           <a:prstGeom prst="rect">
             <a:avLst/>
@@ -4748,20 +4748,20 @@
           <a:noFill/>
         </p:spPr>
         <p:txBody>
-          <a:bodyPr wrap="square">
+          <a:bodyPr wrap="square" anchor="t">
             <a:normAutofit/>
           </a:bodyPr>
           <a:lstStyle/>
           <a:p>
             <a:pPr algn="l"/>
             <a:r>
-              <a:rPr sz="1000" b="0">
+              <a:rPr sz="950" b="0">
                 <a:solidFill>
                   <a:srgbClr val="647082"/>
                 </a:solidFill>
                 <a:latin typeface="Aptos"/>
               </a:rPr>
-              <a:t>filas, 24 columnas</a:t>
+              <a:t>filas</a:t>
             </a:r>
           </a:p>
         </p:txBody>
@@ -4774,8 +4774,8 @@
         </p:nvSpPr>
         <p:spPr>
           <a:xfrm>
-            <a:off x="5852160" y="960120"/>
-            <a:ext cx="2286000" cy="1143000"/>
+            <a:off x="5897880" y="868680"/>
+            <a:ext cx="2331720" cy="1005840"/>
           </a:xfrm>
           <a:prstGeom prst="roundRect">
             <a:avLst/>
@@ -4819,8 +4819,8 @@
         </p:nvSpPr>
         <p:spPr>
           <a:xfrm>
-            <a:off x="6016752" y="1088136"/>
-            <a:ext cx="1956816" cy="256032"/>
+            <a:off x="6035040" y="978407"/>
+            <a:ext cx="2057400" cy="228600"/>
           </a:xfrm>
           <a:prstGeom prst="rect">
             <a:avLst/>
@@ -4828,14 +4828,14 @@
           <a:noFill/>
         </p:spPr>
         <p:txBody>
-          <a:bodyPr wrap="square">
+          <a:bodyPr wrap="square" anchor="t">
             <a:normAutofit/>
           </a:bodyPr>
           <a:lstStyle/>
           <a:p>
             <a:pPr algn="l"/>
             <a:r>
-              <a:rPr sz="1200" b="1">
+              <a:rPr sz="1100" b="1">
                 <a:solidFill>
                   <a:srgbClr val="647082"/>
                 </a:solidFill>
@@ -4854,8 +4854,8 @@
         </p:nvSpPr>
         <p:spPr>
           <a:xfrm>
-            <a:off x="6016752" y="1399032"/>
-            <a:ext cx="1956816" cy="502920"/>
+            <a:off x="6035040" y="1261872"/>
+            <a:ext cx="2057400" cy="411480"/>
           </a:xfrm>
           <a:prstGeom prst="rect">
             <a:avLst/>
@@ -4863,14 +4863,14 @@
           <a:noFill/>
         </p:spPr>
         <p:txBody>
-          <a:bodyPr wrap="square">
+          <a:bodyPr wrap="square" anchor="t">
             <a:normAutofit/>
           </a:bodyPr>
           <a:lstStyle/>
           <a:p>
             <a:pPr algn="l"/>
             <a:r>
-              <a:rPr sz="2400" b="1">
+              <a:rPr sz="2200" b="1">
                 <a:solidFill>
                   <a:srgbClr val="2462BF"/>
                 </a:solidFill>
@@ -4889,8 +4889,8 @@
         </p:nvSpPr>
         <p:spPr>
           <a:xfrm>
-            <a:off x="6016752" y="1947672"/>
-            <a:ext cx="1956816" cy="320040"/>
+            <a:off x="6035040" y="1709928"/>
+            <a:ext cx="2057400" cy="228600"/>
           </a:xfrm>
           <a:prstGeom prst="rect">
             <a:avLst/>
@@ -4898,20 +4898,20 @@
           <a:noFill/>
         </p:spPr>
         <p:txBody>
-          <a:bodyPr wrap="square">
+          <a:bodyPr wrap="square" anchor="t">
             <a:normAutofit/>
           </a:bodyPr>
           <a:lstStyle/>
           <a:p>
             <a:pPr algn="l"/>
             <a:r>
-              <a:rPr sz="1000" b="0">
+              <a:rPr sz="950" b="0">
                 <a:solidFill>
                   <a:srgbClr val="647082"/>
                 </a:solidFill>
                 <a:latin typeface="Aptos"/>
               </a:rPr>
-              <a:t>filas, 23 columnas</a:t>
+              <a:t>filas</a:t>
             </a:r>
           </a:p>
         </p:txBody>
@@ -4924,8 +4924,8 @@
         </p:nvSpPr>
         <p:spPr>
           <a:xfrm>
-            <a:off x="8458200" y="960120"/>
-            <a:ext cx="2286000" cy="1143000"/>
+            <a:off x="8549640" y="868680"/>
+            <a:ext cx="2331720" cy="1005840"/>
           </a:xfrm>
           <a:prstGeom prst="roundRect">
             <a:avLst/>
@@ -4969,8 +4969,8 @@
         </p:nvSpPr>
         <p:spPr>
           <a:xfrm>
-            <a:off x="8622792" y="1088136"/>
-            <a:ext cx="1956816" cy="256032"/>
+            <a:off x="8686800" y="978407"/>
+            <a:ext cx="2057400" cy="228600"/>
           </a:xfrm>
           <a:prstGeom prst="rect">
             <a:avLst/>
@@ -4978,20 +4978,20 @@
           <a:noFill/>
         </p:spPr>
         <p:txBody>
-          <a:bodyPr wrap="square">
+          <a:bodyPr wrap="square" anchor="t">
             <a:normAutofit/>
           </a:bodyPr>
           <a:lstStyle/>
           <a:p>
             <a:pPr algn="l"/>
             <a:r>
-              <a:rPr sz="1200" b="1">
+              <a:rPr sz="1100" b="1">
                 <a:solidFill>
                   <a:srgbClr val="647082"/>
                 </a:solidFill>
                 <a:latin typeface="Aptos"/>
               </a:rPr>
-              <a:t>Metrica</a:t>
+              <a:t>Métrica</a:t>
             </a:r>
           </a:p>
         </p:txBody>
@@ -5004,8 +5004,8 @@
         </p:nvSpPr>
         <p:spPr>
           <a:xfrm>
-            <a:off x="8622792" y="1399032"/>
-            <a:ext cx="1956816" cy="502920"/>
+            <a:off x="8686800" y="1261872"/>
+            <a:ext cx="2057400" cy="411480"/>
           </a:xfrm>
           <a:prstGeom prst="rect">
             <a:avLst/>
@@ -5013,14 +5013,14 @@
           <a:noFill/>
         </p:spPr>
         <p:txBody>
-          <a:bodyPr wrap="square">
+          <a:bodyPr wrap="square" anchor="t">
             <a:normAutofit/>
           </a:bodyPr>
           <a:lstStyle/>
           <a:p>
             <a:pPr algn="l"/>
             <a:r>
-              <a:rPr sz="2400" b="1">
+              <a:rPr sz="2200" b="1">
                 <a:solidFill>
                   <a:srgbClr val="2462BF"/>
                 </a:solidFill>
@@ -5039,8 +5039,8 @@
         </p:nvSpPr>
         <p:spPr>
           <a:xfrm>
-            <a:off x="8622792" y="1947672"/>
-            <a:ext cx="1956816" cy="320040"/>
+            <a:off x="8686800" y="1709928"/>
+            <a:ext cx="2057400" cy="228600"/>
           </a:xfrm>
           <a:prstGeom prst="rect">
             <a:avLst/>
@@ -5048,27 +5048,72 @@
           <a:noFill/>
         </p:spPr>
         <p:txBody>
-          <a:bodyPr wrap="square">
+          <a:bodyPr wrap="square" anchor="t">
             <a:normAutofit/>
           </a:bodyPr>
           <a:lstStyle/>
           <a:p>
             <a:pPr algn="l"/>
             <a:r>
-              <a:rPr sz="1000" b="0">
+              <a:rPr sz="950" b="0">
                 <a:solidFill>
                   <a:srgbClr val="647082"/>
                 </a:solidFill>
                 <a:latin typeface="Aptos"/>
               </a:rPr>
-              <a:t>leaderboard publico</a:t>
-            </a:r>
+              <a:t>leaderboard público</a:t>
+            </a:r>
+          </a:p>
+        </p:txBody>
+      </p:sp>
+      <p:sp>
+        <p:nvSpPr>
+          <p:cNvPr id="20" name="Rounded Rectangle 19"/>
+          <p:cNvSpPr/>
+          <p:nvPr/>
+        </p:nvSpPr>
+        <p:spPr>
+          <a:xfrm>
+            <a:off x="502920" y="2057400"/>
+            <a:ext cx="5394960" cy="3246120"/>
+          </a:xfrm>
+          <a:prstGeom prst="roundRect">
+            <a:avLst/>
+          </a:prstGeom>
+          <a:solidFill>
+            <a:srgbClr val="F4F7FB"/>
+          </a:solidFill>
+          <a:ln>
+            <a:solidFill>
+              <a:srgbClr val="DCE2EC"/>
+            </a:solidFill>
+          </a:ln>
+        </p:spPr>
+        <p:style>
+          <a:lnRef idx="1">
+            <a:schemeClr val="accent1"/>
+          </a:lnRef>
+          <a:fillRef idx="3">
+            <a:schemeClr val="accent1"/>
+          </a:fillRef>
+          <a:effectRef idx="2">
+            <a:schemeClr val="accent1"/>
+          </a:effectRef>
+          <a:fontRef idx="minor">
+            <a:schemeClr val="lt1"/>
+          </a:fontRef>
+        </p:style>
+        <p:txBody>
+          <a:bodyPr rtlCol="0" anchor="ctr"/>
+          <a:lstStyle/>
+          <a:p>
+            <a:pPr algn="ctr"/>
           </a:p>
         </p:txBody>
       </p:sp>
       <p:pic>
         <p:nvPicPr>
-          <p:cNvPr id="20" name="Picture 19" descr="eda_shift_generos_train_test_canva.png"/>
+          <p:cNvPr id="21" name="Picture 20" descr="eda_shift_generos_train_test_canva.png"/>
           <p:cNvPicPr>
             <a:picLocks noChangeAspect="1"/>
           </p:cNvPicPr>
@@ -5082,17 +5127,62 @@
         </p:blipFill>
         <p:spPr>
           <a:xfrm>
-            <a:off x="685800" y="2423160"/>
-            <a:ext cx="5303520" cy="2983230"/>
+            <a:off x="685800" y="2197417"/>
+            <a:ext cx="5029200" cy="2828925"/>
           </a:xfrm>
           <a:prstGeom prst="rect">
             <a:avLst/>
           </a:prstGeom>
         </p:spPr>
       </p:pic>
+      <p:sp>
+        <p:nvSpPr>
+          <p:cNvPr id="22" name="Rounded Rectangle 21"/>
+          <p:cNvSpPr/>
+          <p:nvPr/>
+        </p:nvSpPr>
+        <p:spPr>
+          <a:xfrm>
+            <a:off x="6263640" y="2057400"/>
+            <a:ext cx="5394960" cy="3246120"/>
+          </a:xfrm>
+          <a:prstGeom prst="roundRect">
+            <a:avLst/>
+          </a:prstGeom>
+          <a:solidFill>
+            <a:srgbClr val="F4F7FB"/>
+          </a:solidFill>
+          <a:ln>
+            <a:solidFill>
+              <a:srgbClr val="DCE2EC"/>
+            </a:solidFill>
+          </a:ln>
+        </p:spPr>
+        <p:style>
+          <a:lnRef idx="1">
+            <a:schemeClr val="accent1"/>
+          </a:lnRef>
+          <a:fillRef idx="3">
+            <a:schemeClr val="accent1"/>
+          </a:fillRef>
+          <a:effectRef idx="2">
+            <a:schemeClr val="accent1"/>
+          </a:effectRef>
+          <a:fontRef idx="minor">
+            <a:schemeClr val="lt1"/>
+          </a:fontRef>
+        </p:style>
+        <p:txBody>
+          <a:bodyPr rtlCol="0" anchor="ctr"/>
+          <a:lstStyle/>
+          <a:p>
+            <a:pPr algn="ctr"/>
+          </a:p>
+        </p:txBody>
+      </p:sp>
       <p:pic>
         <p:nvPicPr>
-          <p:cNvPr id="21" name="Picture 20" descr="eda_popularidad_subgenero_canva.png"/>
+          <p:cNvPr id="23" name="Picture 22" descr="eda_popularidad_subgenero_canva.png"/>
           <p:cNvPicPr>
             <a:picLocks noChangeAspect="1"/>
           </p:cNvPicPr>
@@ -5106,8 +5196,8 @@
         </p:blipFill>
         <p:spPr>
           <a:xfrm>
-            <a:off x="6309360" y="2423160"/>
-            <a:ext cx="5074920" cy="2854642"/>
+            <a:off x="6446520" y="2197417"/>
+            <a:ext cx="5029200" cy="2828925"/>
           </a:xfrm>
           <a:prstGeom prst="rect">
             <a:avLst/>
@@ -5116,14 +5206,14 @@
       </p:pic>
       <p:sp>
         <p:nvSpPr>
-          <p:cNvPr id="22" name="TextBox 21"/>
+          <p:cNvPr id="24" name="TextBox 23"/>
           <p:cNvSpPr txBox="1"/>
           <p:nvPr/>
         </p:nvSpPr>
         <p:spPr>
           <a:xfrm>
-            <a:off x="822960" y="6053328"/>
-            <a:ext cx="10698480" cy="320040"/>
+            <a:off x="777240" y="5715000"/>
+            <a:ext cx="10652760" cy="502920"/>
           </a:xfrm>
           <a:prstGeom prst="rect">
             <a:avLst/>
@@ -5131,7 +5221,7 @@
           <a:noFill/>
         </p:spPr>
         <p:txBody>
-          <a:bodyPr wrap="square">
+          <a:bodyPr wrap="square" anchor="t">
             <a:normAutofit/>
           </a:bodyPr>
           <a:lstStyle/>
@@ -5144,7 +5234,7 @@
                 </a:solidFill>
                 <a:latin typeface="Aptos"/>
               </a:rPr>
-              <a:t>Punto clave: train y test no tenian la misma composicion. Esto hizo que la validacion interna no alcanzara para elegir el mejor submit.</a:t>
+              <a:t>Punto clave: train y test no tenían la misma composición. Por eso la validación interna no alcanzaba para elegir el mejor submit.</a:t>
             </a:r>
           </a:p>
         </p:txBody>
@@ -5184,7 +5274,7 @@
         <p:spPr>
           <a:xfrm>
             <a:off x="0" y="0"/>
-            <a:ext cx="12191695" cy="658368"/>
+            <a:ext cx="12191695" cy="621792"/>
           </a:xfrm>
           <a:prstGeom prst="rect">
             <a:avLst/>
@@ -5226,8 +5316,8 @@
         </p:nvSpPr>
         <p:spPr>
           <a:xfrm>
-            <a:off x="411480" y="118872"/>
-            <a:ext cx="10789920" cy="411480"/>
+            <a:off x="411480" y="109728"/>
+            <a:ext cx="11064240" cy="384048"/>
           </a:xfrm>
           <a:prstGeom prst="rect">
             <a:avLst/>
@@ -5235,14 +5325,14 @@
           <a:noFill/>
         </p:spPr>
         <p:txBody>
-          <a:bodyPr wrap="square">
+          <a:bodyPr wrap="square" anchor="t">
             <a:normAutofit/>
           </a:bodyPr>
           <a:lstStyle/>
           <a:p>
             <a:pPr algn="l"/>
             <a:r>
-              <a:rPr sz="2300" b="1">
+              <a:rPr sz="2200" b="1">
                 <a:solidFill>
                   <a:srgbClr val="FFFFFF"/>
                 </a:solidFill>
@@ -5261,8 +5351,8 @@
         </p:nvSpPr>
         <p:spPr>
           <a:xfrm>
-            <a:off x="685800" y="932688"/>
-            <a:ext cx="5303520" cy="411480"/>
+            <a:off x="685800" y="914400"/>
+            <a:ext cx="5166360" cy="320040"/>
           </a:xfrm>
           <a:prstGeom prst="rect">
             <a:avLst/>
@@ -5270,20 +5360,20 @@
           <a:noFill/>
         </p:spPr>
         <p:txBody>
-          <a:bodyPr wrap="square">
+          <a:bodyPr wrap="square" anchor="t">
             <a:normAutofit/>
           </a:bodyPr>
           <a:lstStyle/>
           <a:p>
             <a:pPr algn="l"/>
             <a:r>
-              <a:rPr sz="2400" b="1">
+              <a:rPr sz="2300" b="1">
                 <a:solidFill>
                   <a:srgbClr val="0A1F44"/>
                 </a:solidFill>
                 <a:latin typeface="Aptos"/>
               </a:rPr>
-              <a:t>Baseline usado: CatBoost inicial</a:t>
+              <a:t>Baseline: CatBoost inicial</a:t>
             </a:r>
           </a:p>
         </p:txBody>
@@ -5296,8 +5386,8 @@
         </p:nvSpPr>
         <p:spPr>
           <a:xfrm>
-            <a:off x="731520" y="1417320"/>
-            <a:ext cx="5257800" cy="3291840"/>
+            <a:off x="713232" y="1417320"/>
+            <a:ext cx="5166360" cy="2743200"/>
           </a:xfrm>
           <a:prstGeom prst="rect">
             <a:avLst/>
@@ -5305,16 +5395,16 @@
           <a:noFill/>
         </p:spPr>
         <p:txBody>
-          <a:bodyPr wrap="square" lIns="45720" rIns="45720">
-            <a:spAutoFit/>
+          <a:bodyPr wrap="square" lIns="73152" rIns="73152" tIns="18288">
+            <a:normAutofit/>
           </a:bodyPr>
           <a:lstStyle/>
           <a:p>
             <a:pPr>
               <a:spcAft>
-                <a:spcPts val="800"/>
+                <a:spcPts val="500"/>
               </a:spcAft>
-              <a:defRPr sz="1700">
+              <a:defRPr sz="1550">
                 <a:solidFill>
                   <a:srgbClr val="232D3C"/>
                 </a:solidFill>
@@ -5322,15 +5412,15 @@
               </a:defRPr>
             </a:pPr>
             <a:r>
-              <a:t>Modelo rapido de referencia para tener una primera vara competitiva.</a:t>
+              <a:t>Modelo rápido para tener una primera vara competitiva.</a:t>
             </a:r>
           </a:p>
           <a:p>
             <a:pPr>
               <a:spcAft>
-                <a:spcPts val="800"/>
+                <a:spcPts val="500"/>
               </a:spcAft>
-              <a:defRPr sz="1700">
+              <a:defRPr sz="1550">
                 <a:solidFill>
                   <a:srgbClr val="232D3C"/>
                 </a:solidFill>
@@ -5338,15 +5428,15 @@
               </a:defRPr>
             </a:pPr>
             <a:r>
-              <a:t>Uso 157 features procesadas: audio, fechas, duracion, frecuencias, target encoding OOF y variables de contexto.</a:t>
+              <a:t>Usó 157 features procesadas: audio, fechas, duración, frecuencias, target encoding OOF y contexto.</a:t>
             </a:r>
           </a:p>
           <a:p>
             <a:pPr>
               <a:spcAft>
-                <a:spcPts val="800"/>
+                <a:spcPts val="500"/>
               </a:spcAft>
-              <a:defRPr sz="1700">
+              <a:defRPr sz="1550">
                 <a:solidFill>
                   <a:srgbClr val="232D3C"/>
                 </a:solidFill>
@@ -5354,15 +5444,15 @@
               </a:defRPr>
             </a:pPr>
             <a:r>
-              <a:t>Variables categoricas directas: genre, subgenre, key, mode, key_mode y genre_subgenre.</a:t>
+              <a:t>Categóricas directas: género, subgénero, key, mode, key_mode y genre_subgenre.</a:t>
             </a:r>
           </a:p>
           <a:p>
             <a:pPr>
               <a:spcAft>
-                <a:spcPts val="800"/>
+                <a:spcPts val="500"/>
               </a:spcAft>
-              <a:defRPr sz="1700">
+              <a:defRPr sz="1550">
                 <a:solidFill>
                   <a:srgbClr val="232D3C"/>
                 </a:solidFill>
@@ -5370,15 +5460,15 @@
               </a:defRPr>
             </a:pPr>
             <a:r>
-              <a:t>Validacion: GroupKFold por track_id para evitar que la misma cancion aparezca en train y validacion.</a:t>
+              <a:t>Validación: GroupKFold por track_id para evitar leakage.</a:t>
             </a:r>
           </a:p>
           <a:p>
             <a:pPr>
               <a:spcAft>
-                <a:spcPts val="800"/>
+                <a:spcPts val="500"/>
               </a:spcAft>
-              <a:defRPr sz="1700">
+              <a:defRPr sz="1550">
                 <a:solidFill>
                   <a:srgbClr val="232D3C"/>
                 </a:solidFill>
@@ -5386,45 +5476,21 @@
               </a:defRPr>
             </a:pPr>
             <a:r>
-              <a:t>Ademas aplico lookup para 800 canciones del test ya vistas en train.</a:t>
-            </a:r>
-          </a:p>
-        </p:txBody>
-      </p:sp>
-      <p:pic>
-        <p:nvPicPr>
-          <p:cNvPr id="6" name="Picture 5" descr="baseline_catboost_brecha_generalizacion_canva.png"/>
-          <p:cNvPicPr>
-            <a:picLocks noChangeAspect="1"/>
-          </p:cNvPicPr>
-          <p:nvPr/>
-        </p:nvPicPr>
-        <p:blipFill>
-          <a:blip r:embed="rId2"/>
-          <a:stretch>
-            <a:fillRect/>
-          </a:stretch>
-        </p:blipFill>
-        <p:spPr>
-          <a:xfrm>
-            <a:off x="6172200" y="960120"/>
-            <a:ext cx="5166360" cy="2907622"/>
-          </a:xfrm>
-          <a:prstGeom prst="rect">
-            <a:avLst/>
-          </a:prstGeom>
-        </p:spPr>
-      </p:pic>
-      <p:sp>
-        <p:nvSpPr>
-          <p:cNvPr id="7" name="Rounded Rectangle 6"/>
+              <a:t>Lookup para 800 canciones del test ya vistas en train.</a:t>
+            </a:r>
+          </a:p>
+        </p:txBody>
+      </p:sp>
+      <p:sp>
+        <p:nvSpPr>
+          <p:cNvPr id="6" name="Rounded Rectangle 5"/>
           <p:cNvSpPr/>
           <p:nvPr/>
         </p:nvSpPr>
         <p:spPr>
           <a:xfrm>
-            <a:off x="822960" y="5257800"/>
-            <a:ext cx="2286000" cy="914400"/>
+            <a:off x="6172200" y="914400"/>
+            <a:ext cx="5303520" cy="3337560"/>
           </a:xfrm>
           <a:prstGeom prst="roundRect">
             <a:avLst/>
@@ -5460,121 +5526,40 @@
           </a:p>
         </p:txBody>
       </p:sp>
-      <p:sp>
-        <p:nvSpPr>
-          <p:cNvPr id="8" name="TextBox 7"/>
-          <p:cNvSpPr txBox="1"/>
-          <p:nvPr/>
-        </p:nvSpPr>
-        <p:spPr>
-          <a:xfrm>
-            <a:off x="987552" y="5385816"/>
-            <a:ext cx="1956816" cy="256032"/>
-          </a:xfrm>
-          <a:prstGeom prst="rect">
-            <a:avLst/>
-          </a:prstGeom>
-          <a:noFill/>
-        </p:spPr>
-        <p:txBody>
-          <a:bodyPr wrap="square">
-            <a:normAutofit/>
-          </a:bodyPr>
-          <a:lstStyle/>
-          <a:p>
-            <a:pPr algn="l"/>
-            <a:r>
-              <a:rPr sz="1200" b="1">
-                <a:solidFill>
-                  <a:srgbClr val="647082"/>
-                </a:solidFill>
-                <a:latin typeface="Aptos"/>
-              </a:rPr>
-              <a:t>OOF R2</a:t>
-            </a:r>
-          </a:p>
-        </p:txBody>
-      </p:sp>
-      <p:sp>
-        <p:nvSpPr>
-          <p:cNvPr id="9" name="TextBox 8"/>
-          <p:cNvSpPr txBox="1"/>
-          <p:nvPr/>
-        </p:nvSpPr>
-        <p:spPr>
-          <a:xfrm>
-            <a:off x="987552" y="5696712"/>
-            <a:ext cx="1956816" cy="502920"/>
-          </a:xfrm>
-          <a:prstGeom prst="rect">
-            <a:avLst/>
-          </a:prstGeom>
-          <a:noFill/>
-        </p:spPr>
-        <p:txBody>
-          <a:bodyPr wrap="square">
-            <a:normAutofit/>
-          </a:bodyPr>
-          <a:lstStyle/>
-          <a:p>
-            <a:pPr algn="l"/>
-            <a:r>
-              <a:rPr sz="2400" b="1">
-                <a:solidFill>
-                  <a:srgbClr val="40B7DA"/>
-                </a:solidFill>
-                <a:latin typeface="Aptos"/>
-              </a:rPr>
-              <a:t>0,6520</a:t>
-            </a:r>
-          </a:p>
-        </p:txBody>
-      </p:sp>
-      <p:sp>
-        <p:nvSpPr>
-          <p:cNvPr id="10" name="TextBox 9"/>
-          <p:cNvSpPr txBox="1"/>
-          <p:nvPr/>
-        </p:nvSpPr>
-        <p:spPr>
-          <a:xfrm>
-            <a:off x="987552" y="6245352"/>
-            <a:ext cx="1956816" cy="320040"/>
-          </a:xfrm>
-          <a:prstGeom prst="rect">
-            <a:avLst/>
-          </a:prstGeom>
-          <a:noFill/>
-        </p:spPr>
-        <p:txBody>
-          <a:bodyPr wrap="square">
-            <a:normAutofit/>
-          </a:bodyPr>
-          <a:lstStyle/>
-          <a:p>
-            <a:pPr algn="l"/>
-            <a:r>
-              <a:rPr sz="1000" b="0">
-                <a:solidFill>
-                  <a:srgbClr val="647082"/>
-                </a:solidFill>
-                <a:latin typeface="Aptos"/>
-              </a:rPr>
-              <a:t>validacion interna</a:t>
-            </a:r>
-          </a:p>
-        </p:txBody>
-      </p:sp>
-      <p:sp>
-        <p:nvSpPr>
-          <p:cNvPr id="11" name="Rounded Rectangle 10"/>
+      <p:pic>
+        <p:nvPicPr>
+          <p:cNvPr id="7" name="Picture 6" descr="baseline_catboost_brecha_generalizacion_canva.png"/>
+          <p:cNvPicPr>
+            <a:picLocks noChangeAspect="1"/>
+          </p:cNvPicPr>
+          <p:nvPr/>
+        </p:nvPicPr>
+        <p:blipFill>
+          <a:blip r:embed="rId2"/>
+          <a:stretch>
+            <a:fillRect/>
+          </a:stretch>
+        </p:blipFill>
+        <p:spPr>
+          <a:xfrm>
+            <a:off x="6355080" y="1147976"/>
+            <a:ext cx="4937760" cy="2778966"/>
+          </a:xfrm>
+          <a:prstGeom prst="rect">
+            <a:avLst/>
+          </a:prstGeom>
+        </p:spPr>
+      </p:pic>
+      <p:sp>
+        <p:nvSpPr>
+          <p:cNvPr id="8" name="Rounded Rectangle 7"/>
           <p:cNvSpPr/>
           <p:nvPr/>
         </p:nvSpPr>
         <p:spPr>
           <a:xfrm>
-            <a:off x="3337560" y="5257800"/>
-            <a:ext cx="2286000" cy="914400"/>
+            <a:off x="777240" y="4892040"/>
+            <a:ext cx="2240280" cy="914400"/>
           </a:xfrm>
           <a:prstGeom prst="roundRect">
             <a:avLst/>
@@ -5612,14 +5597,14 @@
       </p:sp>
       <p:sp>
         <p:nvSpPr>
-          <p:cNvPr id="12" name="TextBox 11"/>
+          <p:cNvPr id="9" name="TextBox 8"/>
           <p:cNvSpPr txBox="1"/>
           <p:nvPr/>
         </p:nvSpPr>
         <p:spPr>
           <a:xfrm>
-            <a:off x="3502152" y="5385816"/>
-            <a:ext cx="1956816" cy="256032"/>
+            <a:off x="914400" y="5001768"/>
+            <a:ext cx="1965960" cy="228600"/>
           </a:xfrm>
           <a:prstGeom prst="rect">
             <a:avLst/>
@@ -5627,34 +5612,34 @@
           <a:noFill/>
         </p:spPr>
         <p:txBody>
-          <a:bodyPr wrap="square">
+          <a:bodyPr wrap="square" anchor="t">
             <a:normAutofit/>
           </a:bodyPr>
           <a:lstStyle/>
           <a:p>
             <a:pPr algn="l"/>
             <a:r>
-              <a:rPr sz="1200" b="1">
+              <a:rPr sz="1100" b="1">
                 <a:solidFill>
                   <a:srgbClr val="647082"/>
                 </a:solidFill>
                 <a:latin typeface="Aptos"/>
               </a:rPr>
-              <a:t>Publico</a:t>
-            </a:r>
-          </a:p>
-        </p:txBody>
-      </p:sp>
-      <p:sp>
-        <p:nvSpPr>
-          <p:cNvPr id="13" name="TextBox 12"/>
+              <a:t>OOF R2</a:t>
+            </a:r>
+          </a:p>
+        </p:txBody>
+      </p:sp>
+      <p:sp>
+        <p:nvSpPr>
+          <p:cNvPr id="10" name="TextBox 9"/>
           <p:cNvSpPr txBox="1"/>
           <p:nvPr/>
         </p:nvSpPr>
         <p:spPr>
           <a:xfrm>
-            <a:off x="3502152" y="5696712"/>
-            <a:ext cx="1956816" cy="502920"/>
+            <a:off x="914400" y="5285231"/>
+            <a:ext cx="1965960" cy="411480"/>
           </a:xfrm>
           <a:prstGeom prst="rect">
             <a:avLst/>
@@ -5662,34 +5647,34 @@
           <a:noFill/>
         </p:spPr>
         <p:txBody>
-          <a:bodyPr wrap="square">
+          <a:bodyPr wrap="square" anchor="t">
             <a:normAutofit/>
           </a:bodyPr>
           <a:lstStyle/>
           <a:p>
             <a:pPr algn="l"/>
             <a:r>
-              <a:rPr sz="2400" b="1">
-                <a:solidFill>
-                  <a:srgbClr val="28A745"/>
+              <a:rPr sz="2200" b="1">
+                <a:solidFill>
+                  <a:srgbClr val="40B7DA"/>
                 </a:solidFill>
                 <a:latin typeface="Aptos"/>
               </a:rPr>
-              <a:t>0,36930</a:t>
-            </a:r>
-          </a:p>
-        </p:txBody>
-      </p:sp>
-      <p:sp>
-        <p:nvSpPr>
-          <p:cNvPr id="14" name="TextBox 13"/>
+              <a:t>0,6520</a:t>
+            </a:r>
+          </a:p>
+        </p:txBody>
+      </p:sp>
+      <p:sp>
+        <p:nvSpPr>
+          <p:cNvPr id="11" name="TextBox 10"/>
           <p:cNvSpPr txBox="1"/>
           <p:nvPr/>
         </p:nvSpPr>
         <p:spPr>
           <a:xfrm>
-            <a:off x="3502152" y="6245352"/>
-            <a:ext cx="1956816" cy="320040"/>
+            <a:off x="914400" y="5733288"/>
+            <a:ext cx="1965960" cy="228600"/>
           </a:xfrm>
           <a:prstGeom prst="rect">
             <a:avLst/>
@@ -5697,34 +5682,34 @@
           <a:noFill/>
         </p:spPr>
         <p:txBody>
-          <a:bodyPr wrap="square">
+          <a:bodyPr wrap="square" anchor="t">
             <a:normAutofit/>
           </a:bodyPr>
           <a:lstStyle/>
           <a:p>
             <a:pPr algn="l"/>
             <a:r>
-              <a:rPr sz="1000" b="0">
+              <a:rPr sz="950" b="0">
                 <a:solidFill>
                   <a:srgbClr val="647082"/>
                 </a:solidFill>
                 <a:latin typeface="Aptos"/>
               </a:rPr>
-              <a:t>catboost_best_submit</a:t>
-            </a:r>
-          </a:p>
-        </p:txBody>
-      </p:sp>
-      <p:sp>
-        <p:nvSpPr>
-          <p:cNvPr id="15" name="Rounded Rectangle 14"/>
+              <a:t>validación interna</a:t>
+            </a:r>
+          </a:p>
+        </p:txBody>
+      </p:sp>
+      <p:sp>
+        <p:nvSpPr>
+          <p:cNvPr id="12" name="Rounded Rectangle 11"/>
           <p:cNvSpPr/>
           <p:nvPr/>
         </p:nvSpPr>
         <p:spPr>
           <a:xfrm>
-            <a:off x="5852160" y="5257800"/>
-            <a:ext cx="2286000" cy="914400"/>
+            <a:off x="3246120" y="4892040"/>
+            <a:ext cx="2240280" cy="914400"/>
           </a:xfrm>
           <a:prstGeom prst="roundRect">
             <a:avLst/>
@@ -5762,14 +5747,14 @@
       </p:sp>
       <p:sp>
         <p:nvSpPr>
-          <p:cNvPr id="16" name="TextBox 15"/>
+          <p:cNvPr id="13" name="TextBox 12"/>
           <p:cNvSpPr txBox="1"/>
           <p:nvPr/>
         </p:nvSpPr>
         <p:spPr>
           <a:xfrm>
-            <a:off x="6016752" y="5385816"/>
-            <a:ext cx="1956816" cy="256032"/>
+            <a:off x="3383279" y="5001768"/>
+            <a:ext cx="1965960" cy="228600"/>
           </a:xfrm>
           <a:prstGeom prst="rect">
             <a:avLst/>
@@ -5777,34 +5762,34 @@
           <a:noFill/>
         </p:spPr>
         <p:txBody>
-          <a:bodyPr wrap="square">
+          <a:bodyPr wrap="square" anchor="t">
             <a:normAutofit/>
           </a:bodyPr>
           <a:lstStyle/>
           <a:p>
             <a:pPr algn="l"/>
             <a:r>
-              <a:rPr sz="1200" b="1">
+              <a:rPr sz="1100" b="1">
                 <a:solidFill>
                   <a:srgbClr val="647082"/>
                 </a:solidFill>
                 <a:latin typeface="Aptos"/>
               </a:rPr>
-              <a:t>RMSE OOF</a:t>
-            </a:r>
-          </a:p>
-        </p:txBody>
-      </p:sp>
-      <p:sp>
-        <p:nvSpPr>
-          <p:cNvPr id="17" name="TextBox 16"/>
+              <a:t>Público</a:t>
+            </a:r>
+          </a:p>
+        </p:txBody>
+      </p:sp>
+      <p:sp>
+        <p:nvSpPr>
+          <p:cNvPr id="14" name="TextBox 13"/>
           <p:cNvSpPr txBox="1"/>
           <p:nvPr/>
         </p:nvSpPr>
         <p:spPr>
           <a:xfrm>
-            <a:off x="6016752" y="5696712"/>
-            <a:ext cx="1956816" cy="502920"/>
+            <a:off x="3383279" y="5285231"/>
+            <a:ext cx="1965960" cy="411480"/>
           </a:xfrm>
           <a:prstGeom prst="rect">
             <a:avLst/>
@@ -5812,34 +5797,34 @@
           <a:noFill/>
         </p:spPr>
         <p:txBody>
-          <a:bodyPr wrap="square">
+          <a:bodyPr wrap="square" anchor="t">
             <a:normAutofit/>
           </a:bodyPr>
           <a:lstStyle/>
           <a:p>
             <a:pPr algn="l"/>
             <a:r>
-              <a:rPr sz="2400" b="1">
-                <a:solidFill>
-                  <a:srgbClr val="2462BF"/>
+              <a:rPr sz="2200" b="1">
+                <a:solidFill>
+                  <a:srgbClr val="28A745"/>
                 </a:solidFill>
                 <a:latin typeface="Aptos"/>
               </a:rPr>
-              <a:t>14,743</a:t>
-            </a:r>
-          </a:p>
-        </p:txBody>
-      </p:sp>
-      <p:sp>
-        <p:nvSpPr>
-          <p:cNvPr id="18" name="TextBox 17"/>
+              <a:t>0,36930</a:t>
+            </a:r>
+          </a:p>
+        </p:txBody>
+      </p:sp>
+      <p:sp>
+        <p:nvSpPr>
+          <p:cNvPr id="15" name="TextBox 14"/>
           <p:cNvSpPr txBox="1"/>
           <p:nvPr/>
         </p:nvSpPr>
         <p:spPr>
           <a:xfrm>
-            <a:off x="6016752" y="6245352"/>
-            <a:ext cx="1956816" cy="320040"/>
+            <a:off x="3383279" y="5733288"/>
+            <a:ext cx="1965960" cy="228600"/>
           </a:xfrm>
           <a:prstGeom prst="rect">
             <a:avLst/>
@@ -5847,34 +5832,34 @@
           <a:noFill/>
         </p:spPr>
         <p:txBody>
-          <a:bodyPr wrap="square">
+          <a:bodyPr wrap="square" anchor="t">
             <a:normAutofit/>
           </a:bodyPr>
           <a:lstStyle/>
           <a:p>
             <a:pPr algn="l"/>
             <a:r>
-              <a:rPr sz="1000" b="0">
+              <a:rPr sz="950" b="0">
                 <a:solidFill>
                   <a:srgbClr val="647082"/>
                 </a:solidFill>
                 <a:latin typeface="Aptos"/>
               </a:rPr>
-              <a:t>GroupKFold</a:t>
-            </a:r>
-          </a:p>
-        </p:txBody>
-      </p:sp>
-      <p:sp>
-        <p:nvSpPr>
-          <p:cNvPr id="19" name="Rounded Rectangle 18"/>
+              <a:t>catboost_best_submit</a:t>
+            </a:r>
+          </a:p>
+        </p:txBody>
+      </p:sp>
+      <p:sp>
+        <p:nvSpPr>
+          <p:cNvPr id="16" name="Rounded Rectangle 15"/>
           <p:cNvSpPr/>
           <p:nvPr/>
         </p:nvSpPr>
         <p:spPr>
           <a:xfrm>
-            <a:off x="8366760" y="5257800"/>
-            <a:ext cx="2286000" cy="914400"/>
+            <a:off x="5715000" y="4892040"/>
+            <a:ext cx="2240280" cy="914400"/>
           </a:xfrm>
           <a:prstGeom prst="roundRect">
             <a:avLst/>
@@ -5912,14 +5897,14 @@
       </p:sp>
       <p:sp>
         <p:nvSpPr>
-          <p:cNvPr id="20" name="TextBox 19"/>
+          <p:cNvPr id="17" name="TextBox 16"/>
           <p:cNvSpPr txBox="1"/>
           <p:nvPr/>
         </p:nvSpPr>
         <p:spPr>
           <a:xfrm>
-            <a:off x="8531352" y="5385816"/>
-            <a:ext cx="1956816" cy="256032"/>
+            <a:off x="5852160" y="5001768"/>
+            <a:ext cx="1965960" cy="228600"/>
           </a:xfrm>
           <a:prstGeom prst="rect">
             <a:avLst/>
@@ -5927,14 +5912,164 @@
           <a:noFill/>
         </p:spPr>
         <p:txBody>
-          <a:bodyPr wrap="square">
+          <a:bodyPr wrap="square" anchor="t">
             <a:normAutofit/>
           </a:bodyPr>
           <a:lstStyle/>
           <a:p>
             <a:pPr algn="l"/>
             <a:r>
-              <a:rPr sz="1200" b="1">
+              <a:rPr sz="1100" b="1">
+                <a:solidFill>
+                  <a:srgbClr val="647082"/>
+                </a:solidFill>
+                <a:latin typeface="Aptos"/>
+              </a:rPr>
+              <a:t>RMSE OOF</a:t>
+            </a:r>
+          </a:p>
+        </p:txBody>
+      </p:sp>
+      <p:sp>
+        <p:nvSpPr>
+          <p:cNvPr id="18" name="TextBox 17"/>
+          <p:cNvSpPr txBox="1"/>
+          <p:nvPr/>
+        </p:nvSpPr>
+        <p:spPr>
+          <a:xfrm>
+            <a:off x="5852160" y="5285231"/>
+            <a:ext cx="1965960" cy="411480"/>
+          </a:xfrm>
+          <a:prstGeom prst="rect">
+            <a:avLst/>
+          </a:prstGeom>
+          <a:noFill/>
+        </p:spPr>
+        <p:txBody>
+          <a:bodyPr wrap="square" anchor="t">
+            <a:normAutofit/>
+          </a:bodyPr>
+          <a:lstStyle/>
+          <a:p>
+            <a:pPr algn="l"/>
+            <a:r>
+              <a:rPr sz="2200" b="1">
+                <a:solidFill>
+                  <a:srgbClr val="2462BF"/>
+                </a:solidFill>
+                <a:latin typeface="Aptos"/>
+              </a:rPr>
+              <a:t>14,743</a:t>
+            </a:r>
+          </a:p>
+        </p:txBody>
+      </p:sp>
+      <p:sp>
+        <p:nvSpPr>
+          <p:cNvPr id="19" name="TextBox 18"/>
+          <p:cNvSpPr txBox="1"/>
+          <p:nvPr/>
+        </p:nvSpPr>
+        <p:spPr>
+          <a:xfrm>
+            <a:off x="5852160" y="5733288"/>
+            <a:ext cx="1965960" cy="228600"/>
+          </a:xfrm>
+          <a:prstGeom prst="rect">
+            <a:avLst/>
+          </a:prstGeom>
+          <a:noFill/>
+        </p:spPr>
+        <p:txBody>
+          <a:bodyPr wrap="square" anchor="t">
+            <a:normAutofit/>
+          </a:bodyPr>
+          <a:lstStyle/>
+          <a:p>
+            <a:pPr algn="l"/>
+            <a:r>
+              <a:rPr sz="950" b="0">
+                <a:solidFill>
+                  <a:srgbClr val="647082"/>
+                </a:solidFill>
+                <a:latin typeface="Aptos"/>
+              </a:rPr>
+              <a:t>GroupKFold</a:t>
+            </a:r>
+          </a:p>
+        </p:txBody>
+      </p:sp>
+      <p:sp>
+        <p:nvSpPr>
+          <p:cNvPr id="20" name="Rounded Rectangle 19"/>
+          <p:cNvSpPr/>
+          <p:nvPr/>
+        </p:nvSpPr>
+        <p:spPr>
+          <a:xfrm>
+            <a:off x="8183879" y="4892040"/>
+            <a:ext cx="2240280" cy="914400"/>
+          </a:xfrm>
+          <a:prstGeom prst="roundRect">
+            <a:avLst/>
+          </a:prstGeom>
+          <a:solidFill>
+            <a:srgbClr val="F4F7FB"/>
+          </a:solidFill>
+          <a:ln>
+            <a:solidFill>
+              <a:srgbClr val="DCE2EC"/>
+            </a:solidFill>
+          </a:ln>
+        </p:spPr>
+        <p:style>
+          <a:lnRef idx="1">
+            <a:schemeClr val="accent1"/>
+          </a:lnRef>
+          <a:fillRef idx="3">
+            <a:schemeClr val="accent1"/>
+          </a:fillRef>
+          <a:effectRef idx="2">
+            <a:schemeClr val="accent1"/>
+          </a:effectRef>
+          <a:fontRef idx="minor">
+            <a:schemeClr val="lt1"/>
+          </a:fontRef>
+        </p:style>
+        <p:txBody>
+          <a:bodyPr rtlCol="0" anchor="ctr"/>
+          <a:lstStyle/>
+          <a:p>
+            <a:pPr algn="ctr"/>
+          </a:p>
+        </p:txBody>
+      </p:sp>
+      <p:sp>
+        <p:nvSpPr>
+          <p:cNvPr id="21" name="TextBox 20"/>
+          <p:cNvSpPr txBox="1"/>
+          <p:nvPr/>
+        </p:nvSpPr>
+        <p:spPr>
+          <a:xfrm>
+            <a:off x="8321040" y="5001768"/>
+            <a:ext cx="1965960" cy="228600"/>
+          </a:xfrm>
+          <a:prstGeom prst="rect">
+            <a:avLst/>
+          </a:prstGeom>
+          <a:noFill/>
+        </p:spPr>
+        <p:txBody>
+          <a:bodyPr wrap="square" anchor="t">
+            <a:normAutofit/>
+          </a:bodyPr>
+          <a:lstStyle/>
+          <a:p>
+            <a:pPr algn="l"/>
+            <a:r>
+              <a:rPr sz="1100" b="1">
                 <a:solidFill>
                   <a:srgbClr val="647082"/>
                 </a:solidFill>
@@ -5947,14 +6082,14 @@
       </p:sp>
       <p:sp>
         <p:nvSpPr>
-          <p:cNvPr id="21" name="TextBox 20"/>
+          <p:cNvPr id="22" name="TextBox 21"/>
           <p:cNvSpPr txBox="1"/>
           <p:nvPr/>
         </p:nvSpPr>
         <p:spPr>
           <a:xfrm>
-            <a:off x="8531352" y="5696712"/>
-            <a:ext cx="1956816" cy="502920"/>
+            <a:off x="8321040" y="5285231"/>
+            <a:ext cx="1965960" cy="411480"/>
           </a:xfrm>
           <a:prstGeom prst="rect">
             <a:avLst/>
@@ -5962,14 +6097,14 @@
           <a:noFill/>
         </p:spPr>
         <p:txBody>
-          <a:bodyPr wrap="square">
+          <a:bodyPr wrap="square" anchor="t">
             <a:normAutofit/>
           </a:bodyPr>
           <a:lstStyle/>
           <a:p>
             <a:pPr algn="l"/>
             <a:r>
-              <a:rPr sz="2400" b="1">
+              <a:rPr sz="2200" b="1">
                 <a:solidFill>
                   <a:srgbClr val="FF9F40"/>
                 </a:solidFill>
@@ -5982,14 +6117,14 @@
       </p:sp>
       <p:sp>
         <p:nvSpPr>
-          <p:cNvPr id="22" name="TextBox 21"/>
+          <p:cNvPr id="23" name="TextBox 22"/>
           <p:cNvSpPr txBox="1"/>
           <p:nvPr/>
         </p:nvSpPr>
         <p:spPr>
           <a:xfrm>
-            <a:off x="8531352" y="6245352"/>
-            <a:ext cx="1956816" cy="320040"/>
+            <a:off x="8321040" y="5733288"/>
+            <a:ext cx="1965960" cy="228600"/>
           </a:xfrm>
           <a:prstGeom prst="rect">
             <a:avLst/>
@@ -5997,14 +6132,14 @@
           <a:noFill/>
         </p:spPr>
         <p:txBody>
-          <a:bodyPr wrap="square">
+          <a:bodyPr wrap="square" anchor="t">
             <a:normAutofit/>
           </a:bodyPr>
           <a:lstStyle/>
           <a:p>
             <a:pPr algn="l"/>
             <a:r>
-              <a:rPr sz="1000" b="0">
+              <a:rPr sz="950" b="0">
                 <a:solidFill>
                   <a:srgbClr val="647082"/>
                 </a:solidFill>
@@ -6050,7 +6185,7 @@
         <p:spPr>
           <a:xfrm>
             <a:off x="0" y="0"/>
-            <a:ext cx="12191695" cy="658368"/>
+            <a:ext cx="12191695" cy="621792"/>
           </a:xfrm>
           <a:prstGeom prst="rect">
             <a:avLst/>
@@ -6092,8 +6227,8 @@
         </p:nvSpPr>
         <p:spPr>
           <a:xfrm>
-            <a:off x="411480" y="118872"/>
-            <a:ext cx="10789920" cy="411480"/>
+            <a:off x="411480" y="109728"/>
+            <a:ext cx="11064240" cy="384048"/>
           </a:xfrm>
           <a:prstGeom prst="rect">
             <a:avLst/>
@@ -6101,27 +6236,72 @@
           <a:noFill/>
         </p:spPr>
         <p:txBody>
-          <a:bodyPr wrap="square">
+          <a:bodyPr wrap="square" anchor="t">
             <a:normAutofit/>
           </a:bodyPr>
           <a:lstStyle/>
           <a:p>
             <a:pPr algn="l"/>
             <a:r>
-              <a:rPr sz="2300" b="1">
+              <a:rPr sz="2200" b="1">
                 <a:solidFill>
                   <a:srgbClr val="FFFFFF"/>
                 </a:solidFill>
                 <a:latin typeface="Aptos"/>
               </a:rPr>
-              <a:t>Features y preparacion</a:t>
-            </a:r>
+              <a:t>Features y preparación</a:t>
+            </a:r>
+          </a:p>
+        </p:txBody>
+      </p:sp>
+      <p:sp>
+        <p:nvSpPr>
+          <p:cNvPr id="4" name="Rounded Rectangle 3"/>
+          <p:cNvSpPr/>
+          <p:nvPr/>
+        </p:nvSpPr>
+        <p:spPr>
+          <a:xfrm>
+            <a:off x="502920" y="914400"/>
+            <a:ext cx="5669280" cy="3794760"/>
+          </a:xfrm>
+          <a:prstGeom prst="roundRect">
+            <a:avLst/>
+          </a:prstGeom>
+          <a:solidFill>
+            <a:srgbClr val="F4F7FB"/>
+          </a:solidFill>
+          <a:ln>
+            <a:solidFill>
+              <a:srgbClr val="DCE2EC"/>
+            </a:solidFill>
+          </a:ln>
+        </p:spPr>
+        <p:style>
+          <a:lnRef idx="1">
+            <a:schemeClr val="accent1"/>
+          </a:lnRef>
+          <a:fillRef idx="3">
+            <a:schemeClr val="accent1"/>
+          </a:fillRef>
+          <a:effectRef idx="2">
+            <a:schemeClr val="accent1"/>
+          </a:effectRef>
+          <a:fontRef idx="minor">
+            <a:schemeClr val="lt1"/>
+          </a:fontRef>
+        </p:style>
+        <p:txBody>
+          <a:bodyPr rtlCol="0" anchor="ctr"/>
+          <a:lstStyle/>
+          <a:p>
+            <a:pPr algn="ctr"/>
           </a:p>
         </p:txBody>
       </p:sp>
       <p:pic>
         <p:nvPicPr>
-          <p:cNvPr id="4" name="Picture 3" descr="feature_engineering_variables_canva.png"/>
+          <p:cNvPr id="5" name="Picture 4" descr="feature_engineering_variables_canva.png"/>
           <p:cNvPicPr>
             <a:picLocks noChangeAspect="1"/>
           </p:cNvPicPr>
@@ -6135,8 +6315,8 @@
         </p:blipFill>
         <p:spPr>
           <a:xfrm>
-            <a:off x="502920" y="914400"/>
-            <a:ext cx="5669280" cy="3190665"/>
+            <a:off x="685800" y="1273652"/>
+            <a:ext cx="5303520" cy="2984815"/>
           </a:xfrm>
           <a:prstGeom prst="rect">
             <a:avLst/>
@@ -6145,14 +6325,14 @@
       </p:pic>
       <p:sp>
         <p:nvSpPr>
-          <p:cNvPr id="5" name="TextBox 4"/>
+          <p:cNvPr id="6" name="TextBox 5"/>
           <p:cNvSpPr txBox="1"/>
           <p:nvPr/>
         </p:nvSpPr>
         <p:spPr>
           <a:xfrm>
             <a:off x="6446520" y="960120"/>
-            <a:ext cx="5166360" cy="365760"/>
+            <a:ext cx="5212080" cy="320040"/>
           </a:xfrm>
           <a:prstGeom prst="rect">
             <a:avLst/>
@@ -6160,34 +6340,34 @@
           <a:noFill/>
         </p:spPr>
         <p:txBody>
-          <a:bodyPr wrap="square">
+          <a:bodyPr wrap="square" anchor="t">
             <a:normAutofit/>
           </a:bodyPr>
           <a:lstStyle/>
           <a:p>
             <a:pPr algn="l"/>
             <a:r>
-              <a:rPr sz="2300" b="1">
+              <a:rPr sz="2200" b="1">
                 <a:solidFill>
                   <a:srgbClr val="0A1F44"/>
                 </a:solidFill>
                 <a:latin typeface="Aptos"/>
               </a:rPr>
-              <a:t>La senal no estaba en una sola variable</a:t>
-            </a:r>
-          </a:p>
-        </p:txBody>
-      </p:sp>
-      <p:sp>
-        <p:nvSpPr>
-          <p:cNvPr id="6" name="TextBox 5"/>
+              <a:t>La señal no estaba en una sola variable</a:t>
+            </a:r>
+          </a:p>
+        </p:txBody>
+      </p:sp>
+      <p:sp>
+        <p:nvSpPr>
+          <p:cNvPr id="7" name="TextBox 6"/>
           <p:cNvSpPr txBox="1"/>
           <p:nvPr/>
         </p:nvSpPr>
         <p:spPr>
           <a:xfrm>
-            <a:off x="6492240" y="1463040"/>
-            <a:ext cx="5074920" cy="3566160"/>
+            <a:off x="6492240" y="1444752"/>
+            <a:ext cx="4983480" cy="3246120"/>
           </a:xfrm>
           <a:prstGeom prst="rect">
             <a:avLst/>
@@ -6195,16 +6375,16 @@
           <a:noFill/>
         </p:spPr>
         <p:txBody>
-          <a:bodyPr wrap="square" lIns="45720" rIns="45720">
-            <a:spAutoFit/>
+          <a:bodyPr wrap="square" lIns="73152" rIns="73152" tIns="18288">
+            <a:normAutofit/>
           </a:bodyPr>
           <a:lstStyle/>
           <a:p>
             <a:pPr>
               <a:spcAft>
-                <a:spcPts val="800"/>
+                <a:spcPts val="500"/>
               </a:spcAft>
-              <a:defRPr sz="1700">
+              <a:defRPr sz="1600">
                 <a:solidFill>
                   <a:srgbClr val="232D3C"/>
                 </a:solidFill>
@@ -6212,15 +6392,15 @@
               </a:defRPr>
             </a:pPr>
             <a:r>
-              <a:t>Audio: danceability, energy, valence, tempo, loudness y transformaciones.</a:t>
+              <a:t>Audio: danceability, energy, valence, tempo y loudness.</a:t>
             </a:r>
           </a:p>
           <a:p>
             <a:pPr>
               <a:spcAft>
-                <a:spcPts val="800"/>
+                <a:spcPts val="500"/>
               </a:spcAft>
-              <a:defRPr sz="1700">
+              <a:defRPr sz="1600">
                 <a:solidFill>
                   <a:srgbClr val="232D3C"/>
                 </a:solidFill>
@@ -6228,15 +6408,15 @@
               </a:defRPr>
             </a:pPr>
             <a:r>
-              <a:t>Tiempo: anio, mes, decada, antiguedad y flags de fecha parcial.</a:t>
+              <a:t>Tiempo: año, mes, década, antigüedad y fecha parcial.</a:t>
             </a:r>
           </a:p>
           <a:p>
             <a:pPr>
               <a:spcAft>
-                <a:spcPts val="800"/>
+                <a:spcPts val="500"/>
               </a:spcAft>
-              <a:defRPr sz="1700">
+              <a:defRPr sz="1600">
                 <a:solidFill>
                   <a:srgbClr val="232D3C"/>
                 </a:solidFill>
@@ -6244,15 +6424,15 @@
               </a:defRPr>
             </a:pPr>
             <a:r>
-              <a:t>Contexto: playlist, genero, subgenero, artista y album.</a:t>
+              <a:t>Contexto: playlist, género, subgénero, artista y álbum.</a:t>
             </a:r>
           </a:p>
           <a:p>
             <a:pPr>
               <a:spcAft>
-                <a:spcPts val="800"/>
+                <a:spcPts val="500"/>
               </a:spcAft>
-              <a:defRPr sz="1700">
+              <a:defRPr sz="1600">
                 <a:solidFill>
                   <a:srgbClr val="232D3C"/>
                 </a:solidFill>
@@ -6260,15 +6440,15 @@
               </a:defRPr>
             </a:pPr>
             <a:r>
-              <a:t>Frecuencias train/test para manejar categorias nuevas.</a:t>
+              <a:t>Frecuencias para manejar categorías nuevas.</a:t>
             </a:r>
           </a:p>
           <a:p>
             <a:pPr>
               <a:spcAft>
-                <a:spcPts val="800"/>
+                <a:spcPts val="500"/>
               </a:spcAft>
-              <a:defRPr sz="1700">
+              <a:defRPr sz="1600">
                 <a:solidFill>
                   <a:srgbClr val="232D3C"/>
                 </a:solidFill>
@@ -6282,9 +6462,9 @@
           <a:p>
             <a:pPr>
               <a:spcAft>
-                <a:spcPts val="800"/>
+                <a:spcPts val="500"/>
               </a:spcAft>
-              <a:defRPr sz="1700">
+              <a:defRPr sz="1600">
                 <a:solidFill>
                   <a:srgbClr val="232D3C"/>
                 </a:solidFill>
@@ -6299,14 +6479,14 @@
       </p:sp>
       <p:sp>
         <p:nvSpPr>
-          <p:cNvPr id="7" name="TextBox 6"/>
+          <p:cNvPr id="8" name="TextBox 7"/>
           <p:cNvSpPr txBox="1"/>
           <p:nvPr/>
         </p:nvSpPr>
         <p:spPr>
           <a:xfrm>
-            <a:off x="6537960" y="5486400"/>
-            <a:ext cx="4892040" cy="502920"/>
+            <a:off x="914400" y="5623560"/>
+            <a:ext cx="10332720" cy="457200"/>
           </a:xfrm>
           <a:prstGeom prst="rect">
             <a:avLst/>
@@ -6314,12 +6494,12 @@
           <a:noFill/>
         </p:spPr>
         <p:txBody>
-          <a:bodyPr wrap="square">
+          <a:bodyPr wrap="square" anchor="t">
             <a:normAutofit/>
           </a:bodyPr>
           <a:lstStyle/>
           <a:p>
-            <a:pPr algn="l"/>
+            <a:pPr algn="ctr"/>
             <a:r>
               <a:rPr sz="1600" b="1">
                 <a:solidFill>
@@ -6327,7 +6507,7 @@
                 </a:solidFill>
                 <a:latin typeface="Aptos"/>
               </a:rPr>
-              <a:t>La idea fue combinar senal musical + contexto + robustez frente a categorias no vistas.</a:t>
+              <a:t>Idea central: combinar señal musical, contexto y robustez frente a categorías no vistas.</a:t>
             </a:r>
           </a:p>
         </p:txBody>
@@ -6367,7 +6547,7 @@
         <p:spPr>
           <a:xfrm>
             <a:off x="0" y="0"/>
-            <a:ext cx="12191695" cy="658368"/>
+            <a:ext cx="12191695" cy="621792"/>
           </a:xfrm>
           <a:prstGeom prst="rect">
             <a:avLst/>
@@ -6409,8 +6589,8 @@
         </p:nvSpPr>
         <p:spPr>
           <a:xfrm>
-            <a:off x="411480" y="118872"/>
-            <a:ext cx="10789920" cy="411480"/>
+            <a:off x="411480" y="109728"/>
+            <a:ext cx="11064240" cy="384048"/>
           </a:xfrm>
           <a:prstGeom prst="rect">
             <a:avLst/>
@@ -6418,27 +6598,72 @@
           <a:noFill/>
         </p:spPr>
         <p:txBody>
-          <a:bodyPr wrap="square">
+          <a:bodyPr wrap="square" anchor="t">
             <a:normAutofit/>
           </a:bodyPr>
           <a:lstStyle/>
           <a:p>
             <a:pPr algn="l"/>
             <a:r>
-              <a:rPr sz="2300" b="1">
+              <a:rPr sz="2200" b="1">
                 <a:solidFill>
                   <a:srgbClr val="FFFFFF"/>
                 </a:solidFill>
                 <a:latin typeface="Aptos"/>
               </a:rPr>
-              <a:t>Seleccion de modelos: que se probo</a:t>
-            </a:r>
+              <a:t>Selección de modelos: qué se probó</a:t>
+            </a:r>
+          </a:p>
+        </p:txBody>
+      </p:sp>
+      <p:sp>
+        <p:nvSpPr>
+          <p:cNvPr id="4" name="Rounded Rectangle 3"/>
+          <p:cNvSpPr/>
+          <p:nvPr/>
+        </p:nvSpPr>
+        <p:spPr>
+          <a:xfrm>
+            <a:off x="548640" y="868680"/>
+            <a:ext cx="11109960" cy="5074920"/>
+          </a:xfrm>
+          <a:prstGeom prst="roundRect">
+            <a:avLst/>
+          </a:prstGeom>
+          <a:solidFill>
+            <a:srgbClr val="F4F7FB"/>
+          </a:solidFill>
+          <a:ln>
+            <a:solidFill>
+              <a:srgbClr val="DCE2EC"/>
+            </a:solidFill>
+          </a:ln>
+        </p:spPr>
+        <p:style>
+          <a:lnRef idx="1">
+            <a:schemeClr val="accent1"/>
+          </a:lnRef>
+          <a:fillRef idx="3">
+            <a:schemeClr val="accent1"/>
+          </a:fillRef>
+          <a:effectRef idx="2">
+            <a:schemeClr val="accent1"/>
+          </a:effectRef>
+          <a:fontRef idx="minor">
+            <a:schemeClr val="lt1"/>
+          </a:fontRef>
+        </p:style>
+        <p:txBody>
+          <a:bodyPr rtlCol="0" anchor="ctr"/>
+          <a:lstStyle/>
+          <a:p>
+            <a:pPr algn="ctr"/>
           </a:p>
         </p:txBody>
       </p:sp>
       <p:pic>
         <p:nvPicPr>
-          <p:cNvPr id="4" name="Picture 3" descr="timeline_todos_submits_canva.png"/>
+          <p:cNvPr id="5" name="Picture 4" descr="timeline_todos_submits_canva.png"/>
           <p:cNvPicPr>
             <a:picLocks noChangeAspect="1"/>
           </p:cNvPicPr>
@@ -6452,8 +6677,8 @@
         </p:blipFill>
         <p:spPr>
           <a:xfrm>
-            <a:off x="502920" y="914400"/>
-            <a:ext cx="11064240" cy="6223635"/>
+            <a:off x="1958340" y="1024128"/>
+            <a:ext cx="8290559" cy="4663440"/>
           </a:xfrm>
           <a:prstGeom prst="rect">
             <a:avLst/>
@@ -6462,14 +6687,14 @@
       </p:pic>
       <p:sp>
         <p:nvSpPr>
-          <p:cNvPr id="5" name="TextBox 4"/>
+          <p:cNvPr id="6" name="TextBox 5"/>
           <p:cNvSpPr txBox="1"/>
           <p:nvPr/>
         </p:nvSpPr>
         <p:spPr>
           <a:xfrm>
-            <a:off x="731520" y="5715000"/>
-            <a:ext cx="10607040" cy="548640"/>
+            <a:off x="868680" y="6080760"/>
+            <a:ext cx="10469880" cy="411480"/>
           </a:xfrm>
           <a:prstGeom prst="rect">
             <a:avLst/>
@@ -6477,20 +6702,20 @@
           <a:noFill/>
         </p:spPr>
         <p:txBody>
-          <a:bodyPr wrap="square">
+          <a:bodyPr wrap="square" anchor="t">
             <a:normAutofit/>
           </a:bodyPr>
           <a:lstStyle/>
           <a:p>
             <a:pPr algn="ctr"/>
             <a:r>
-              <a:rPr sz="1600" b="1">
+              <a:rPr sz="1450" b="1">
                 <a:solidFill>
                   <a:srgbClr val="232D3C"/>
                 </a:solidFill>
                 <a:latin typeface="Aptos"/>
               </a:rPr>
-              <a:t>Este grafico resume la secuencia real de pruebas: se avanzo de modelos base a feature selection, postprocesos, ExtraTrees, reglas por subgenero y finalmente probes de leaderboard.</a:t>
+              <a:t>El gráfico resume la secuencia real: modelos base, feature selection, postprocesos, ExtraTrees, reglas por subgénero y probes de leaderboard.</a:t>
             </a:r>
           </a:p>
         </p:txBody>
@@ -6530,7 +6755,7 @@
         <p:spPr>
           <a:xfrm>
             <a:off x="0" y="0"/>
-            <a:ext cx="12191695" cy="658368"/>
+            <a:ext cx="12191695" cy="621792"/>
           </a:xfrm>
           <a:prstGeom prst="rect">
             <a:avLst/>
@@ -6572,8 +6797,8 @@
         </p:nvSpPr>
         <p:spPr>
           <a:xfrm>
-            <a:off x="411480" y="118872"/>
-            <a:ext cx="10789920" cy="411480"/>
+            <a:off x="411480" y="109728"/>
+            <a:ext cx="11064240" cy="384048"/>
           </a:xfrm>
           <a:prstGeom prst="rect">
             <a:avLst/>
@@ -6581,20 +6806,20 @@
           <a:noFill/>
         </p:spPr>
         <p:txBody>
-          <a:bodyPr wrap="square">
+          <a:bodyPr wrap="square" anchor="t">
             <a:normAutofit/>
           </a:bodyPr>
           <a:lstStyle/>
           <a:p>
             <a:pPr algn="l"/>
             <a:r>
-              <a:rPr sz="2300" b="1">
+              <a:rPr sz="2200" b="1">
                 <a:solidFill>
                   <a:srgbClr val="FFFFFF"/>
                 </a:solidFill>
                 <a:latin typeface="Aptos"/>
               </a:rPr>
-              <a:t>Estrategia de evaluacion y busqueda</a:t>
+              <a:t>Estrategia de evaluación y búsqueda</a:t>
             </a:r>
           </a:p>
         </p:txBody>
@@ -6607,8 +6832,8 @@
         </p:nvSpPr>
         <p:spPr>
           <a:xfrm>
-            <a:off x="685800" y="960120"/>
-            <a:ext cx="5394960" cy="411480"/>
+            <a:off x="685800" y="914400"/>
+            <a:ext cx="5349240" cy="320040"/>
           </a:xfrm>
           <a:prstGeom prst="rect">
             <a:avLst/>
@@ -6616,20 +6841,20 @@
           <a:noFill/>
         </p:spPr>
         <p:txBody>
-          <a:bodyPr wrap="square">
+          <a:bodyPr wrap="square" anchor="t">
             <a:normAutofit/>
           </a:bodyPr>
           <a:lstStyle/>
           <a:p>
             <a:pPr algn="l"/>
             <a:r>
-              <a:rPr sz="2300" b="1">
+              <a:rPr sz="2200" b="1">
                 <a:solidFill>
                   <a:srgbClr val="0A1F44"/>
                 </a:solidFill>
                 <a:latin typeface="Aptos"/>
               </a:rPr>
-              <a:t>Como se decidio que probar</a:t>
+              <a:t>Cómo se decidió qué probar</a:t>
             </a:r>
           </a:p>
         </p:txBody>
@@ -6642,8 +6867,8 @@
         </p:nvSpPr>
         <p:spPr>
           <a:xfrm>
-            <a:off x="731520" y="1481328"/>
-            <a:ext cx="5303520" cy="4389120"/>
+            <a:off x="731520" y="1417320"/>
+            <a:ext cx="5212080" cy="4160520"/>
           </a:xfrm>
           <a:prstGeom prst="rect">
             <a:avLst/>
@@ -6651,14 +6876,14 @@
           <a:noFill/>
         </p:spPr>
         <p:txBody>
-          <a:bodyPr wrap="square" lIns="45720" rIns="45720">
-            <a:spAutoFit/>
+          <a:bodyPr wrap="square" lIns="73152" rIns="73152" tIns="18288">
+            <a:normAutofit/>
           </a:bodyPr>
           <a:lstStyle/>
           <a:p>
             <a:pPr>
               <a:spcAft>
-                <a:spcPts val="800"/>
+                <a:spcPts val="500"/>
               </a:spcAft>
               <a:defRPr sz="1700">
                 <a:solidFill>
@@ -6668,13 +6893,13 @@
               </a:defRPr>
             </a:pPr>
             <a:r>
-              <a:t>Validacion interna con GroupKFold por track_id: util para comparar modelos sin leakage de canciones repetidas.</a:t>
+              <a:t>GroupKFold por track_id para comparar sin leakage.</a:t>
             </a:r>
           </a:p>
           <a:p>
             <a:pPr>
               <a:spcAft>
-                <a:spcPts val="800"/>
+                <a:spcPts val="500"/>
               </a:spcAft>
               <a:defRPr sz="1700">
                 <a:solidFill>
@@ -6684,13 +6909,13 @@
               </a:defRPr>
             </a:pPr>
             <a:r>
-              <a:t>Leaderboard publico como diagnostico externo: mostro drift fuerte entre train y test.</a:t>
+              <a:t>Leaderboard público como diagnóstico externo del drift.</a:t>
             </a:r>
           </a:p>
           <a:p>
             <a:pPr>
               <a:spcAft>
-                <a:spcPts val="800"/>
+                <a:spcPts val="500"/>
               </a:spcAft>
               <a:defRPr sz="1700">
                 <a:solidFill>
@@ -6700,13 +6925,13 @@
               </a:defRPr>
             </a:pPr>
             <a:r>
-              <a:t>Cambios graduales: no se reemplazo todo el pipeline de golpe; se probo una hipotesis por vez.</a:t>
+              <a:t>Cambios graduales: una hipótesis por vez.</a:t>
             </a:r>
           </a:p>
           <a:p>
             <a:pPr>
               <a:spcAft>
-                <a:spcPts val="800"/>
+                <a:spcPts val="500"/>
               </a:spcAft>
               <a:defRPr sz="1700">
                 <a:solidFill>
@@ -6716,7 +6941,7 @@
               </a:defRPr>
             </a:pPr>
             <a:r>
-              <a:t>Se registro cada submit con nombre exacto y R2 publico para evitar confundir ramas.</a:t>
+              <a:t>Registro de cada submit con nombre exacto y R2 público.</a:t>
             </a:r>
           </a:p>
         </p:txBody>
@@ -6729,8 +6954,8 @@
         </p:nvSpPr>
         <p:spPr>
           <a:xfrm>
-            <a:off x="6400800" y="960120"/>
-            <a:ext cx="5120640" cy="411480"/>
+            <a:off x="6400800" y="914400"/>
+            <a:ext cx="5120640" cy="320040"/>
           </a:xfrm>
           <a:prstGeom prst="rect">
             <a:avLst/>
@@ -6738,14 +6963,14 @@
           <a:noFill/>
         </p:spPr>
         <p:txBody>
-          <a:bodyPr wrap="square">
+          <a:bodyPr wrap="square" anchor="t">
             <a:normAutofit/>
           </a:bodyPr>
           <a:lstStyle/>
           <a:p>
             <a:pPr algn="l"/>
             <a:r>
-              <a:rPr sz="2300" b="1">
+              <a:rPr sz="2200" b="1">
                 <a:solidFill>
                   <a:srgbClr val="0A1F44"/>
                 </a:solidFill>
@@ -6764,7 +6989,7 @@
         </p:nvSpPr>
         <p:spPr>
           <a:xfrm>
-            <a:off x="6446520" y="1481328"/>
+            <a:off x="6446520" y="1417320"/>
             <a:ext cx="4983480" cy="4389120"/>
           </a:xfrm>
           <a:prstGeom prst="rect">
@@ -6773,16 +6998,16 @@
           <a:noFill/>
         </p:spPr>
         <p:txBody>
-          <a:bodyPr wrap="square" lIns="45720" rIns="45720">
-            <a:spAutoFit/>
+          <a:bodyPr wrap="square" lIns="73152" rIns="73152" tIns="18288">
+            <a:normAutofit/>
           </a:bodyPr>
           <a:lstStyle/>
           <a:p>
             <a:pPr>
               <a:spcAft>
-                <a:spcPts val="800"/>
+                <a:spcPts val="500"/>
               </a:spcAft>
-              <a:defRPr sz="1700">
+              <a:defRPr sz="1600">
                 <a:solidFill>
                   <a:srgbClr val="232D3C"/>
                 </a:solidFill>
@@ -6790,15 +7015,15 @@
               </a:defRPr>
             </a:pPr>
             <a:r>
-              <a:t>CatBoost base y variantes sin/con target encoding.</a:t>
+              <a:t>CatBoost base y variantes con/sin target encoding.</a:t>
             </a:r>
           </a:p>
           <a:p>
             <a:pPr>
               <a:spcAft>
-                <a:spcPts val="800"/>
+                <a:spcPts val="500"/>
               </a:spcAft>
-              <a:defRPr sz="1700">
+              <a:defRPr sz="1600">
                 <a:solidFill>
                   <a:srgbClr val="232D3C"/>
                 </a:solidFill>
@@ -6806,15 +7031,15 @@
               </a:defRPr>
             </a:pPr>
             <a:r>
-              <a:t>CatBoost con seleccion de features: top 60, top 90, top 120.</a:t>
+              <a:t>CatBoost top 60, top 90 y top 120.</a:t>
             </a:r>
           </a:p>
           <a:p>
             <a:pPr>
               <a:spcAft>
-                <a:spcPts val="800"/>
+                <a:spcPts val="500"/>
               </a:spcAft>
-              <a:defRPr sz="1700">
+              <a:defRPr sz="1600">
                 <a:solidFill>
                   <a:srgbClr val="232D3C"/>
                 </a:solidFill>
@@ -6822,15 +7047,15 @@
               </a:defRPr>
             </a:pPr>
             <a:r>
-              <a:t>Ajustes de hiperparametros y postprocesos conservadores.</a:t>
+              <a:t>Ajustes de hiperparámetros y postprocesos.</a:t>
             </a:r>
           </a:p>
           <a:p>
             <a:pPr>
               <a:spcAft>
-                <a:spcPts val="800"/>
+                <a:spcPts val="500"/>
               </a:spcAft>
-              <a:defRPr sz="1700">
+              <a:defRPr sz="1600">
                 <a:solidFill>
                   <a:srgbClr val="232D3C"/>
                 </a:solidFill>
@@ -6838,15 +7063,15 @@
               </a:defRPr>
             </a:pPr>
             <a:r>
-              <a:t>LightGBM y ExtraTrees como fuentes de diversidad.</a:t>
+              <a:t>LightGBM y ExtraTrees para diversidad.</a:t>
             </a:r>
           </a:p>
           <a:p>
             <a:pPr>
               <a:spcAft>
-                <a:spcPts val="800"/>
+                <a:spcPts val="500"/>
               </a:spcAft>
-              <a:defRPr sz="1700">
+              <a:defRPr sz="1600">
                 <a:solidFill>
                   <a:srgbClr val="232D3C"/>
                 </a:solidFill>
@@ -6854,15 +7079,15 @@
               </a:defRPr>
             </a:pPr>
             <a:r>
-              <a:t>Ensambles por ranking para preservar distribucion.</a:t>
+              <a:t>Ensambles por ranking para preservar distribución.</a:t>
             </a:r>
           </a:p>
           <a:p>
             <a:pPr>
               <a:spcAft>
-                <a:spcPts val="800"/>
+                <a:spcPts val="500"/>
               </a:spcAft>
-              <a:defRPr sz="1700">
+              <a:defRPr sz="1600">
                 <a:solidFill>
                   <a:srgbClr val="232D3C"/>
                 </a:solidFill>
@@ -6870,15 +7095,15 @@
               </a:defRPr>
             </a:pPr>
             <a:r>
-              <a:t>Reglas localizadas sobre subgeneros no vistos.</a:t>
+              <a:t>Reglas localizadas por subgénero.</a:t>
             </a:r>
           </a:p>
           <a:p>
             <a:pPr>
               <a:spcAft>
-                <a:spcPts val="800"/>
+                <a:spcPts val="500"/>
               </a:spcAft>
-              <a:defRPr sz="1700">
+              <a:defRPr sz="1600">
                 <a:solidFill>
                   <a:srgbClr val="232D3C"/>
                 </a:solidFill>
@@ -6886,7 +7111,7 @@
               </a:defRPr>
             </a:pPr>
             <a:r>
-              <a:t>Probes de leaderboard como experimento final de competencia.</a:t>
+              <a:t>Probes de leaderboard como experimento final.</a:t>
             </a:r>
           </a:p>
         </p:txBody>
@@ -6926,7 +7151,7 @@
         <p:spPr>
           <a:xfrm>
             <a:off x="0" y="0"/>
-            <a:ext cx="12191695" cy="658368"/>
+            <a:ext cx="12191695" cy="621792"/>
           </a:xfrm>
           <a:prstGeom prst="rect">
             <a:avLst/>
@@ -6968,8 +7193,8 @@
         </p:nvSpPr>
         <p:spPr>
           <a:xfrm>
-            <a:off x="411480" y="118872"/>
-            <a:ext cx="10789920" cy="411480"/>
+            <a:off x="411480" y="109728"/>
+            <a:ext cx="11064240" cy="384048"/>
           </a:xfrm>
           <a:prstGeom prst="rect">
             <a:avLst/>
@@ -6977,14 +7202,14 @@
           <a:noFill/>
         </p:spPr>
         <p:txBody>
-          <a:bodyPr wrap="square">
+          <a:bodyPr wrap="square" anchor="t">
             <a:normAutofit/>
           </a:bodyPr>
           <a:lstStyle/>
           <a:p>
             <a:pPr algn="l"/>
             <a:r>
-              <a:rPr sz="2300" b="1">
+              <a:rPr sz="2200" b="1">
                 <a:solidFill>
                   <a:srgbClr val="FFFFFF"/>
                 </a:solidFill>
@@ -7003,8 +7228,8 @@
         </p:nvSpPr>
         <p:spPr>
           <a:xfrm>
-            <a:off x="685800" y="932688"/>
-            <a:ext cx="10972800" cy="411480"/>
+            <a:off x="640080" y="868680"/>
+            <a:ext cx="10972800" cy="320040"/>
           </a:xfrm>
           <a:prstGeom prst="rect">
             <a:avLst/>
@@ -7012,20 +7237,20 @@
           <a:noFill/>
         </p:spPr>
         <p:txBody>
-          <a:bodyPr wrap="square">
+          <a:bodyPr wrap="square" anchor="t">
             <a:normAutofit/>
           </a:bodyPr>
           <a:lstStyle/>
           <a:p>
             <a:pPr algn="l"/>
             <a:r>
-              <a:rPr sz="2400" b="1">
+              <a:rPr sz="2100" b="1">
                 <a:solidFill>
                   <a:srgbClr val="0A1F44"/>
                 </a:solidFill>
                 <a:latin typeface="Aptos"/>
               </a:rPr>
-              <a:t>Pipeline reproducible: CatBoost + ExtraTrees + postprocesamiento deterministico</a:t>
+              <a:t>Pipeline reproducible: CatBoost + ExtraTrees + postprocesamiento determinístico</a:t>
             </a:r>
           </a:p>
         </p:txBody>
@@ -7038,8 +7263,8 @@
         </p:nvSpPr>
         <p:spPr>
           <a:xfrm>
-            <a:off x="731520" y="1600200"/>
-            <a:ext cx="2468880" cy="1005840"/>
+            <a:off x="685800" y="1417320"/>
+            <a:ext cx="2423160" cy="914400"/>
           </a:xfrm>
           <a:prstGeom prst="roundRect">
             <a:avLst/>
@@ -7083,8 +7308,8 @@
         </p:nvSpPr>
         <p:spPr>
           <a:xfrm>
-            <a:off x="896112" y="1728216"/>
-            <a:ext cx="2139696" cy="256032"/>
+            <a:off x="822960" y="1527048"/>
+            <a:ext cx="2148840" cy="228600"/>
           </a:xfrm>
           <a:prstGeom prst="rect">
             <a:avLst/>
@@ -7092,14 +7317,14 @@
           <a:noFill/>
         </p:spPr>
         <p:txBody>
-          <a:bodyPr wrap="square">
+          <a:bodyPr wrap="square" anchor="t">
             <a:normAutofit/>
           </a:bodyPr>
           <a:lstStyle/>
           <a:p>
             <a:pPr algn="l"/>
             <a:r>
-              <a:rPr sz="1200" b="1">
+              <a:rPr sz="1100" b="1">
                 <a:solidFill>
                   <a:srgbClr val="647082"/>
                 </a:solidFill>
@@ -7118,8 +7343,8 @@
         </p:nvSpPr>
         <p:spPr>
           <a:xfrm>
-            <a:off x="896112" y="2039112"/>
-            <a:ext cx="2139696" cy="502920"/>
+            <a:off x="822960" y="1810512"/>
+            <a:ext cx="2148840" cy="411480"/>
           </a:xfrm>
           <a:prstGeom prst="rect">
             <a:avLst/>
@@ -7127,14 +7352,14 @@
           <a:noFill/>
         </p:spPr>
         <p:txBody>
-          <a:bodyPr wrap="square">
+          <a:bodyPr wrap="square" anchor="t">
             <a:normAutofit/>
           </a:bodyPr>
           <a:lstStyle/>
           <a:p>
             <a:pPr algn="l"/>
             <a:r>
-              <a:rPr sz="2400" b="1">
+              <a:rPr sz="2200" b="1">
                 <a:solidFill>
                   <a:srgbClr val="28A745"/>
                 </a:solidFill>
@@ -7153,8 +7378,8 @@
         </p:nvSpPr>
         <p:spPr>
           <a:xfrm>
-            <a:off x="896112" y="2587752"/>
-            <a:ext cx="2139696" cy="320040"/>
+            <a:off x="822960" y="2258568"/>
+            <a:ext cx="2148840" cy="228600"/>
           </a:xfrm>
           <a:prstGeom prst="rect">
             <a:avLst/>
@@ -7162,20 +7387,20 @@
           <a:noFill/>
         </p:spPr>
         <p:txBody>
-          <a:bodyPr wrap="square">
+          <a:bodyPr wrap="square" anchor="t">
             <a:normAutofit/>
           </a:bodyPr>
           <a:lstStyle/>
           <a:p>
             <a:pPr algn="l"/>
             <a:r>
-              <a:rPr sz="1000" b="0">
+              <a:rPr sz="950" b="0">
                 <a:solidFill>
                   <a:srgbClr val="647082"/>
                 </a:solidFill>
                 <a:latin typeface="Aptos"/>
               </a:rPr>
-              <a:t>R2 publico</a:t>
+              <a:t>R2 público</a:t>
             </a:r>
           </a:p>
         </p:txBody>
@@ -7188,8 +7413,8 @@
         </p:nvSpPr>
         <p:spPr>
           <a:xfrm>
-            <a:off x="3474720" y="1600200"/>
-            <a:ext cx="2468880" cy="1005840"/>
+            <a:off x="3337560" y="1417320"/>
+            <a:ext cx="2423160" cy="914400"/>
           </a:xfrm>
           <a:prstGeom prst="roundRect">
             <a:avLst/>
@@ -7233,8 +7458,8 @@
         </p:nvSpPr>
         <p:spPr>
           <a:xfrm>
-            <a:off x="3639312" y="1728216"/>
-            <a:ext cx="2139696" cy="256032"/>
+            <a:off x="3474720" y="1527048"/>
+            <a:ext cx="2148840" cy="228600"/>
           </a:xfrm>
           <a:prstGeom prst="rect">
             <a:avLst/>
@@ -7242,14 +7467,14 @@
           <a:noFill/>
         </p:spPr>
         <p:txBody>
-          <a:bodyPr wrap="square">
+          <a:bodyPr wrap="square" anchor="t">
             <a:normAutofit/>
           </a:bodyPr>
           <a:lstStyle/>
           <a:p>
             <a:pPr algn="l"/>
             <a:r>
-              <a:rPr sz="1200" b="1">
+              <a:rPr sz="1100" b="1">
                 <a:solidFill>
                   <a:srgbClr val="647082"/>
                 </a:solidFill>
@@ -7268,8 +7493,8 @@
         </p:nvSpPr>
         <p:spPr>
           <a:xfrm>
-            <a:off x="3639312" y="2039112"/>
-            <a:ext cx="2139696" cy="502920"/>
+            <a:off x="3474720" y="1810512"/>
+            <a:ext cx="2148840" cy="411480"/>
           </a:xfrm>
           <a:prstGeom prst="rect">
             <a:avLst/>
@@ -7277,14 +7502,14 @@
           <a:noFill/>
         </p:spPr>
         <p:txBody>
-          <a:bodyPr wrap="square">
+          <a:bodyPr wrap="square" anchor="t">
             <a:normAutofit/>
           </a:bodyPr>
           <a:lstStyle/>
           <a:p>
             <a:pPr algn="l"/>
             <a:r>
-              <a:rPr sz="2400" b="1">
+              <a:rPr sz="2200" b="1">
                 <a:solidFill>
                   <a:srgbClr val="2462BF"/>
                 </a:solidFill>
@@ -7303,8 +7528,8 @@
         </p:nvSpPr>
         <p:spPr>
           <a:xfrm>
-            <a:off x="3639312" y="2587752"/>
-            <a:ext cx="2139696" cy="320040"/>
+            <a:off x="3474720" y="2258568"/>
+            <a:ext cx="2148840" cy="228600"/>
           </a:xfrm>
           <a:prstGeom prst="rect">
             <a:avLst/>
@@ -7312,14 +7537,14 @@
           <a:noFill/>
         </p:spPr>
         <p:txBody>
-          <a:bodyPr wrap="square">
+          <a:bodyPr wrap="square" anchor="t">
             <a:normAutofit/>
           </a:bodyPr>
           <a:lstStyle/>
           <a:p>
             <a:pPr algn="l"/>
             <a:r>
-              <a:rPr sz="1000" b="0">
+              <a:rPr sz="950" b="0">
                 <a:solidFill>
                   <a:srgbClr val="647082"/>
                 </a:solidFill>
@@ -7338,8 +7563,8 @@
         </p:nvSpPr>
         <p:spPr>
           <a:xfrm>
-            <a:off x="6217920" y="1600200"/>
-            <a:ext cx="2468880" cy="1005840"/>
+            <a:off x="5989320" y="1417320"/>
+            <a:ext cx="2423160" cy="914400"/>
           </a:xfrm>
           <a:prstGeom prst="roundRect">
             <a:avLst/>
@@ -7383,8 +7608,8 @@
         </p:nvSpPr>
         <p:spPr>
           <a:xfrm>
-            <a:off x="6382512" y="1728216"/>
-            <a:ext cx="2139696" cy="256032"/>
+            <a:off x="6126480" y="1527048"/>
+            <a:ext cx="2148840" cy="228600"/>
           </a:xfrm>
           <a:prstGeom prst="rect">
             <a:avLst/>
@@ -7392,14 +7617,14 @@
           <a:noFill/>
         </p:spPr>
         <p:txBody>
-          <a:bodyPr wrap="square">
+          <a:bodyPr wrap="square" anchor="t">
             <a:normAutofit/>
           </a:bodyPr>
           <a:lstStyle/>
           <a:p>
             <a:pPr algn="l"/>
             <a:r>
-              <a:rPr sz="1200" b="1">
+              <a:rPr sz="1100" b="1">
                 <a:solidFill>
                   <a:srgbClr val="647082"/>
                 </a:solidFill>
@@ -7418,8 +7643,8 @@
         </p:nvSpPr>
         <p:spPr>
           <a:xfrm>
-            <a:off x="6382512" y="2039112"/>
-            <a:ext cx="2139696" cy="502920"/>
+            <a:off x="6126480" y="1810512"/>
+            <a:ext cx="2148840" cy="411480"/>
           </a:xfrm>
           <a:prstGeom prst="rect">
             <a:avLst/>
@@ -7427,14 +7652,14 @@
           <a:noFill/>
         </p:spPr>
         <p:txBody>
-          <a:bodyPr wrap="square">
+          <a:bodyPr wrap="square" anchor="t">
             <a:normAutofit/>
           </a:bodyPr>
           <a:lstStyle/>
           <a:p>
             <a:pPr algn="l"/>
             <a:r>
-              <a:rPr sz="2400" b="1">
+              <a:rPr sz="2200" b="1">
                 <a:solidFill>
                   <a:srgbClr val="40B7DA"/>
                 </a:solidFill>
@@ -7453,8 +7678,8 @@
         </p:nvSpPr>
         <p:spPr>
           <a:xfrm>
-            <a:off x="6382512" y="2587752"/>
-            <a:ext cx="2139696" cy="320040"/>
+            <a:off x="6126480" y="2258568"/>
+            <a:ext cx="2148840" cy="228600"/>
           </a:xfrm>
           <a:prstGeom prst="rect">
             <a:avLst/>
@@ -7462,20 +7687,20 @@
           <a:noFill/>
         </p:spPr>
         <p:txBody>
-          <a:bodyPr wrap="square">
+          <a:bodyPr wrap="square" anchor="t">
             <a:normAutofit/>
           </a:bodyPr>
           <a:lstStyle/>
           <a:p>
             <a:pPr algn="l"/>
             <a:r>
-              <a:rPr sz="1000" b="0">
+              <a:rPr sz="950" b="0">
                 <a:solidFill>
                   <a:srgbClr val="647082"/>
                 </a:solidFill>
                 <a:latin typeface="Aptos"/>
               </a:rPr>
-              <a:t>features numericas</a:t>
+              <a:t>features numéricas</a:t>
             </a:r>
           </a:p>
         </p:txBody>
@@ -7488,8 +7713,8 @@
         </p:nvSpPr>
         <p:spPr>
           <a:xfrm>
-            <a:off x="8961120" y="1600200"/>
-            <a:ext cx="2468880" cy="1005840"/>
+            <a:off x="8641080" y="1417320"/>
+            <a:ext cx="2423160" cy="914400"/>
           </a:xfrm>
           <a:prstGeom prst="roundRect">
             <a:avLst/>
@@ -7533,8 +7758,8 @@
         </p:nvSpPr>
         <p:spPr>
           <a:xfrm>
-            <a:off x="9125712" y="1728216"/>
-            <a:ext cx="2139696" cy="256032"/>
+            <a:off x="8778240" y="1527048"/>
+            <a:ext cx="2148840" cy="228600"/>
           </a:xfrm>
           <a:prstGeom prst="rect">
             <a:avLst/>
@@ -7542,14 +7767,14 @@
           <a:noFill/>
         </p:spPr>
         <p:txBody>
-          <a:bodyPr wrap="square">
+          <a:bodyPr wrap="square" anchor="t">
             <a:normAutofit/>
           </a:bodyPr>
           <a:lstStyle/>
           <a:p>
             <a:pPr algn="l"/>
             <a:r>
-              <a:rPr sz="1200" b="1">
+              <a:rPr sz="1100" b="1">
                 <a:solidFill>
                   <a:srgbClr val="647082"/>
                 </a:solidFill>
@@ -7568,8 +7793,8 @@
         </p:nvSpPr>
         <p:spPr>
           <a:xfrm>
-            <a:off x="9125712" y="2039112"/>
-            <a:ext cx="2139696" cy="502920"/>
+            <a:off x="8778240" y="1810512"/>
+            <a:ext cx="2148840" cy="411480"/>
           </a:xfrm>
           <a:prstGeom prst="rect">
             <a:avLst/>
@@ -7577,14 +7802,14 @@
           <a:noFill/>
         </p:spPr>
         <p:txBody>
-          <a:bodyPr wrap="square">
+          <a:bodyPr wrap="square" anchor="t">
             <a:normAutofit/>
           </a:bodyPr>
           <a:lstStyle/>
           <a:p>
             <a:pPr algn="l"/>
             <a:r>
-              <a:rPr sz="2400" b="1">
+              <a:rPr sz="2200" b="1">
                 <a:solidFill>
                   <a:srgbClr val="FF9F40"/>
                 </a:solidFill>
@@ -7603,8 +7828,8 @@
         </p:nvSpPr>
         <p:spPr>
           <a:xfrm>
-            <a:off x="9125712" y="2587752"/>
-            <a:ext cx="2139696" cy="320040"/>
+            <a:off x="8778240" y="2258568"/>
+            <a:ext cx="2148840" cy="228600"/>
           </a:xfrm>
           <a:prstGeom prst="rect">
             <a:avLst/>
@@ -7612,14 +7837,14 @@
           <a:noFill/>
         </p:spPr>
         <p:txBody>
-          <a:bodyPr wrap="square">
+          <a:bodyPr wrap="square" anchor="t">
             <a:normAutofit/>
           </a:bodyPr>
           <a:lstStyle/>
           <a:p>
             <a:pPr algn="l"/>
             <a:r>
-              <a:rPr sz="1000" b="0">
+              <a:rPr sz="950" b="0">
                 <a:solidFill>
                   <a:srgbClr val="647082"/>
                 </a:solidFill>
@@ -7638,8 +7863,8 @@
         </p:nvSpPr>
         <p:spPr>
           <a:xfrm>
-            <a:off x="777240" y="2971800"/>
-            <a:ext cx="5440680" cy="2651760"/>
+            <a:off x="731520" y="2743200"/>
+            <a:ext cx="5349240" cy="2606040"/>
           </a:xfrm>
           <a:prstGeom prst="rect">
             <a:avLst/>
@@ -7647,16 +7872,16 @@
           <a:noFill/>
         </p:spPr>
         <p:txBody>
-          <a:bodyPr wrap="square" lIns="45720" rIns="45720">
-            <a:spAutoFit/>
+          <a:bodyPr wrap="square" lIns="73152" rIns="73152" tIns="18288">
+            <a:normAutofit/>
           </a:bodyPr>
           <a:lstStyle/>
           <a:p>
             <a:pPr>
               <a:spcAft>
-                <a:spcPts val="800"/>
+                <a:spcPts val="500"/>
               </a:spcAft>
-              <a:defRPr sz="1700">
+              <a:defRPr sz="1600">
                 <a:solidFill>
                   <a:srgbClr val="232D3C"/>
                 </a:solidFill>
@@ -7664,15 +7889,15 @@
               </a:defRPr>
             </a:pPr>
             <a:r>
-              <a:t>Se llego al modelo final despues de observar que CatBoost top 60 era el mejor modelo puro publico.</a:t>
+              <a:t>CatBoost top 60 fue el mejor modelo puro público.</a:t>
             </a:r>
           </a:p>
           <a:p>
             <a:pPr>
               <a:spcAft>
-                <a:spcPts val="800"/>
+                <a:spcPts val="500"/>
               </a:spcAft>
-              <a:defRPr sz="1700">
+              <a:defRPr sz="1600">
                 <a:solidFill>
                   <a:srgbClr val="232D3C"/>
                 </a:solidFill>
@@ -7680,15 +7905,15 @@
               </a:defRPr>
             </a:pPr>
             <a:r>
-              <a:t>ExtraTrees no gano solo, pero aporto ranking complementario sobre filas no vistas.</a:t>
+              <a:t>ExtraTrees aportó un ranking complementario en filas no vistas.</a:t>
             </a:r>
           </a:p>
           <a:p>
             <a:pPr>
               <a:spcAft>
-                <a:spcPts val="800"/>
+                <a:spcPts val="500"/>
               </a:spcAft>
-              <a:defRPr sz="1700">
+              <a:defRPr sz="1600">
                 <a:solidFill>
                   <a:srgbClr val="232D3C"/>
                 </a:solidFill>
@@ -7696,15 +7921,15 @@
               </a:defRPr>
             </a:pPr>
             <a:r>
-              <a:t>El ensamble preservo la distribucion del mejor submit y cambio principalmente el orden relativo.</a:t>
+              <a:t>El ensamble preservó la distribución del mejor submit.</a:t>
             </a:r>
           </a:p>
           <a:p>
             <a:pPr>
               <a:spcAft>
-                <a:spcPts val="800"/>
+                <a:spcPts val="500"/>
               </a:spcAft>
-              <a:defRPr sz="1700">
+              <a:defRPr sz="1600">
                 <a:solidFill>
                   <a:srgbClr val="232D3C"/>
                 </a:solidFill>
@@ -7712,14 +7937,59 @@
               </a:defRPr>
             </a:pPr>
             <a:r>
-              <a:t>Las reglas finales bajaron subgeneros puntuales: neo soul y progressive electro house.</a:t>
-            </a:r>
+              <a:t>Las reglas finales ajustaron neo soul y progressive electro house.</a:t>
+            </a:r>
+          </a:p>
+        </p:txBody>
+      </p:sp>
+      <p:sp>
+        <p:nvSpPr>
+          <p:cNvPr id="22" name="Rounded Rectangle 21"/>
+          <p:cNvSpPr/>
+          <p:nvPr/>
+        </p:nvSpPr>
+        <p:spPr>
+          <a:xfrm>
+            <a:off x="6400800" y="2743200"/>
+            <a:ext cx="4892040" cy="2606040"/>
+          </a:xfrm>
+          <a:prstGeom prst="roundRect">
+            <a:avLst/>
+          </a:prstGeom>
+          <a:solidFill>
+            <a:srgbClr val="F4F7FB"/>
+          </a:solidFill>
+          <a:ln>
+            <a:solidFill>
+              <a:srgbClr val="DCE2EC"/>
+            </a:solidFill>
+          </a:ln>
+        </p:spPr>
+        <p:style>
+          <a:lnRef idx="1">
+            <a:schemeClr val="accent1"/>
+          </a:lnRef>
+          <a:fillRef idx="3">
+            <a:schemeClr val="accent1"/>
+          </a:fillRef>
+          <a:effectRef idx="2">
+            <a:schemeClr val="accent1"/>
+          </a:effectRef>
+          <a:fontRef idx="minor">
+            <a:schemeClr val="lt1"/>
+          </a:fontRef>
+        </p:style>
+        <p:txBody>
+          <a:bodyPr rtlCol="0" anchor="ctr"/>
+          <a:lstStyle/>
+          <a:p>
+            <a:pPr algn="ctr"/>
           </a:p>
         </p:txBody>
       </p:sp>
       <p:pic>
         <p:nvPicPr>
-          <p:cNvPr id="22" name="Picture 21" descr="feature_importance_catboost_canva.png"/>
+          <p:cNvPr id="23" name="Picture 22" descr="feature_importance_catboost_canva.png"/>
           <p:cNvPicPr>
             <a:picLocks noChangeAspect="1"/>
           </p:cNvPicPr>
@@ -7733,8 +8003,8 @@
         </p:blipFill>
         <p:spPr>
           <a:xfrm>
-            <a:off x="6400800" y="2880360"/>
-            <a:ext cx="4846320" cy="2726055"/>
+            <a:off x="6798564" y="2862072"/>
+            <a:ext cx="4096511" cy="2304288"/>
           </a:xfrm>
           <a:prstGeom prst="rect">
             <a:avLst/>
@@ -7743,14 +8013,14 @@
       </p:pic>
       <p:sp>
         <p:nvSpPr>
-          <p:cNvPr id="23" name="TextBox 22"/>
+          <p:cNvPr id="24" name="TextBox 23"/>
           <p:cNvSpPr txBox="1"/>
           <p:nvPr/>
         </p:nvSpPr>
         <p:spPr>
           <a:xfrm>
-            <a:off x="822960" y="5943600"/>
-            <a:ext cx="10515600" cy="320040"/>
+            <a:off x="868680" y="5852160"/>
+            <a:ext cx="10378440" cy="384048"/>
           </a:xfrm>
           <a:prstGeom prst="rect">
             <a:avLst/>
@@ -7758,20 +8028,20 @@
           <a:noFill/>
         </p:spPr>
         <p:txBody>
-          <a:bodyPr wrap="square">
+          <a:bodyPr wrap="square" anchor="t">
             <a:normAutofit/>
           </a:bodyPr>
           <a:lstStyle/>
           <a:p>
             <a:pPr algn="ctr"/>
             <a:r>
-              <a:rPr sz="1500" b="1">
+              <a:rPr sz="1450" b="1">
                 <a:solidFill>
                   <a:srgbClr val="232D3C"/>
                 </a:solidFill>
                 <a:latin typeface="Aptos"/>
               </a:rPr>
-              <a:t>Se eligio porque mejora el baseline, es reproducible y se puede defender como pipeline predictivo.</a:t>
+              <a:t>Se eligió porque mejora el baseline, es reproducible y se puede defender como pipeline predictivo.</a:t>
             </a:r>
           </a:p>
         </p:txBody>
@@ -7811,7 +8081,7 @@
         <p:spPr>
           <a:xfrm>
             <a:off x="0" y="0"/>
-            <a:ext cx="12191695" cy="658368"/>
+            <a:ext cx="12191695" cy="621792"/>
           </a:xfrm>
           <a:prstGeom prst="rect">
             <a:avLst/>
@@ -7853,8 +8123,8 @@
         </p:nvSpPr>
         <p:spPr>
           <a:xfrm>
-            <a:off x="411480" y="118872"/>
-            <a:ext cx="10789920" cy="411480"/>
+            <a:off x="411480" y="109728"/>
+            <a:ext cx="11064240" cy="384048"/>
           </a:xfrm>
           <a:prstGeom prst="rect">
             <a:avLst/>
@@ -7862,14 +8132,14 @@
           <a:noFill/>
         </p:spPr>
         <p:txBody>
-          <a:bodyPr wrap="square">
+          <a:bodyPr wrap="square" anchor="t">
             <a:normAutofit/>
           </a:bodyPr>
           <a:lstStyle/>
           <a:p>
             <a:pPr algn="l"/>
             <a:r>
-              <a:rPr sz="2300" b="1">
+              <a:rPr sz="2200" b="1">
                 <a:solidFill>
                   <a:srgbClr val="FFFFFF"/>
                 </a:solidFill>
@@ -7888,8 +8158,8 @@
         </p:nvSpPr>
         <p:spPr>
           <a:xfrm>
-            <a:off x="685800" y="960120"/>
-            <a:ext cx="5349240" cy="411480"/>
+            <a:off x="685800" y="914400"/>
+            <a:ext cx="5394960" cy="320040"/>
           </a:xfrm>
           <a:prstGeom prst="rect">
             <a:avLst/>
@@ -7897,20 +8167,20 @@
           <a:noFill/>
         </p:spPr>
         <p:txBody>
-          <a:bodyPr wrap="square">
+          <a:bodyPr wrap="square" anchor="t">
             <a:normAutofit/>
           </a:bodyPr>
           <a:lstStyle/>
           <a:p>
             <a:pPr algn="l"/>
             <a:r>
-              <a:rPr sz="2500" b="1">
+              <a:rPr sz="2400" b="1">
                 <a:solidFill>
                   <a:srgbClr val="0A1F44"/>
                 </a:solidFill>
                 <a:latin typeface="Aptos"/>
               </a:rPr>
-              <a:t>Mejor submit publico: 0,46155</a:t>
+              <a:t>Mejor submit público: 0,46155</a:t>
             </a:r>
           </a:p>
         </p:txBody>
@@ -7923,8 +8193,8 @@
         </p:nvSpPr>
         <p:spPr>
           <a:xfrm>
-            <a:off x="731520" y="1508760"/>
-            <a:ext cx="5257800" cy="3566160"/>
+            <a:off x="731520" y="1417320"/>
+            <a:ext cx="5257800" cy="3108960"/>
           </a:xfrm>
           <a:prstGeom prst="rect">
             <a:avLst/>
@@ -7932,16 +8202,16 @@
           <a:noFill/>
         </p:spPr>
         <p:txBody>
-          <a:bodyPr wrap="square" lIns="45720" rIns="45720">
-            <a:spAutoFit/>
+          <a:bodyPr wrap="square" lIns="73152" rIns="73152" tIns="18288">
+            <a:normAutofit/>
           </a:bodyPr>
           <a:lstStyle/>
           <a:p>
             <a:pPr>
               <a:spcAft>
-                <a:spcPts val="800"/>
+                <a:spcPts val="500"/>
               </a:spcAft>
-              <a:defRPr sz="1700">
+              <a:defRPr sz="1600">
                 <a:solidFill>
                   <a:srgbClr val="232D3C"/>
                 </a:solidFill>
@@ -7955,9 +8225,9 @@
           <a:p>
             <a:pPr>
               <a:spcAft>
-                <a:spcPts val="800"/>
+                <a:spcPts val="500"/>
               </a:spcAft>
-              <a:defRPr sz="1700">
+              <a:defRPr sz="1600">
                 <a:solidFill>
                   <a:srgbClr val="232D3C"/>
                 </a:solidFill>
@@ -7965,15 +8235,15 @@
               </a:defRPr>
             </a:pPr>
             <a:r>
-              <a:t>No se presenta como modelo principal, sino como optimizacion experimental de competencia.</a:t>
+              <a:t>No se presenta como modelo principal.</a:t>
             </a:r>
           </a:p>
           <a:p>
             <a:pPr>
               <a:spcAft>
-                <a:spcPts val="800"/>
+                <a:spcPts val="500"/>
               </a:spcAft>
-              <a:defRPr sz="1700">
+              <a:defRPr sz="1600">
                 <a:solidFill>
                   <a:srgbClr val="232D3C"/>
                 </a:solidFill>
@@ -7981,15 +8251,15 @@
               </a:defRPr>
             </a:pPr>
             <a:r>
-              <a:t>Combina submits historicos y sus R2 publicos para estimar direcciones de mejora.</a:t>
+              <a:t>Combina submits históricos y sus R2 públicos.</a:t>
             </a:r>
           </a:p>
           <a:p>
             <a:pPr>
               <a:spcAft>
-                <a:spcPts val="800"/>
+                <a:spcPts val="500"/>
               </a:spcAft>
-              <a:defRPr sz="1700">
+              <a:defRPr sz="1600">
                 <a:solidFill>
                   <a:srgbClr val="232D3C"/>
                 </a:solidFill>
@@ -7997,14 +8267,75 @@
               </a:defRPr>
             </a:pPr>
             <a:r>
-              <a:t>Tiene mayor riesgo de sobreajuste al 50% publico del test.</a:t>
-            </a:r>
+              <a:t>Sirve como optimización competitiva.</a:t>
+            </a:r>
+          </a:p>
+          <a:p>
+            <a:pPr>
+              <a:spcAft>
+                <a:spcPts val="500"/>
+              </a:spcAft>
+              <a:defRPr sz="1600">
+                <a:solidFill>
+                  <a:srgbClr val="232D3C"/>
+                </a:solidFill>
+                <a:latin typeface="Aptos"/>
+              </a:defRPr>
+            </a:pPr>
+            <a:r>
+              <a:t>Tiene mayor riesgo de sobreajuste al 50% público.</a:t>
+            </a:r>
+          </a:p>
+        </p:txBody>
+      </p:sp>
+      <p:sp>
+        <p:nvSpPr>
+          <p:cNvPr id="6" name="Rounded Rectangle 5"/>
+          <p:cNvSpPr/>
+          <p:nvPr/>
+        </p:nvSpPr>
+        <p:spPr>
+          <a:xfrm>
+            <a:off x="6309360" y="914400"/>
+            <a:ext cx="5120640" cy="3703320"/>
+          </a:xfrm>
+          <a:prstGeom prst="roundRect">
+            <a:avLst/>
+          </a:prstGeom>
+          <a:solidFill>
+            <a:srgbClr val="F4F7FB"/>
+          </a:solidFill>
+          <a:ln>
+            <a:solidFill>
+              <a:srgbClr val="DCE2EC"/>
+            </a:solidFill>
+          </a:ln>
+        </p:spPr>
+        <p:style>
+          <a:lnRef idx="1">
+            <a:schemeClr val="accent1"/>
+          </a:lnRef>
+          <a:fillRef idx="3">
+            <a:schemeClr val="accent1"/>
+          </a:fillRef>
+          <a:effectRef idx="2">
+            <a:schemeClr val="accent1"/>
+          </a:effectRef>
+          <a:fontRef idx="minor">
+            <a:schemeClr val="lt1"/>
+          </a:fontRef>
+        </p:style>
+        <p:txBody>
+          <a:bodyPr rtlCol="0" anchor="ctr"/>
+          <a:lstStyle/>
+          <a:p>
+            <a:pPr algn="ctr"/>
           </a:p>
         </p:txBody>
       </p:sp>
       <p:pic>
         <p:nvPicPr>
-          <p:cNvPr id="6" name="Picture 5" descr="que_funciono_y_que_no_canva.png"/>
+          <p:cNvPr id="7" name="Picture 6" descr="que_funciono_y_que_no_canva.png"/>
           <p:cNvPicPr>
             <a:picLocks noChangeAspect="1"/>
           </p:cNvPicPr>
@@ -8018,8 +8349,8 @@
         </p:blipFill>
         <p:spPr>
           <a:xfrm>
-            <a:off x="6309360" y="1005840"/>
-            <a:ext cx="5029200" cy="2830429"/>
+            <a:off x="6492240" y="1382319"/>
+            <a:ext cx="4754880" cy="2676041"/>
           </a:xfrm>
           <a:prstGeom prst="rect">
             <a:avLst/>
@@ -8028,14 +8359,14 @@
       </p:pic>
       <p:sp>
         <p:nvSpPr>
-          <p:cNvPr id="7" name="TextBox 6"/>
+          <p:cNvPr id="8" name="TextBox 7"/>
           <p:cNvSpPr txBox="1"/>
           <p:nvPr/>
         </p:nvSpPr>
         <p:spPr>
           <a:xfrm>
-            <a:off x="868680" y="5806440"/>
-            <a:ext cx="10378440" cy="502920"/>
+            <a:off x="868680" y="5577840"/>
+            <a:ext cx="10378440" cy="594360"/>
           </a:xfrm>
           <a:prstGeom prst="rect">
             <a:avLst/>
@@ -8043,7 +8374,7 @@
           <a:noFill/>
         </p:spPr>
         <p:txBody>
-          <a:bodyPr wrap="square">
+          <a:bodyPr wrap="square" anchor="t">
             <a:normAutofit/>
           </a:bodyPr>
           <a:lstStyle/>
@@ -8056,7 +8387,7 @@
                 </a:solidFill>
                 <a:latin typeface="Aptos"/>
               </a:rPr>
-              <a:t>Lectura honesta: el 0,39740 es el modelo final reproducible; el 0,46155 es el mejor resultado de competencia calibrado con feedback del leaderboard.</a:t>
+              <a:t>Lectura honesta: 0,39740 es el modelo final reproducible; 0,46155 es el mejor resultado de competencia calibrado con feedback del leaderboard.</a:t>
             </a:r>
           </a:p>
         </p:txBody>
@@ -8096,7 +8427,7 @@
         <p:spPr>
           <a:xfrm>
             <a:off x="0" y="0"/>
-            <a:ext cx="12191695" cy="658368"/>
+            <a:ext cx="12191695" cy="621792"/>
           </a:xfrm>
           <a:prstGeom prst="rect">
             <a:avLst/>
@@ -8138,8 +8469,8 @@
         </p:nvSpPr>
         <p:spPr>
           <a:xfrm>
-            <a:off x="411480" y="118872"/>
-            <a:ext cx="10789920" cy="411480"/>
+            <a:off x="411480" y="109728"/>
+            <a:ext cx="11064240" cy="384048"/>
           </a:xfrm>
           <a:prstGeom prst="rect">
             <a:avLst/>
@@ -8147,14 +8478,14 @@
           <a:noFill/>
         </p:spPr>
         <p:txBody>
-          <a:bodyPr wrap="square">
+          <a:bodyPr wrap="square" anchor="t">
             <a:normAutofit/>
           </a:bodyPr>
           <a:lstStyle/>
           <a:p>
             <a:pPr algn="l"/>
             <a:r>
-              <a:rPr sz="2300" b="1">
+              <a:rPr sz="2200" b="1">
                 <a:solidFill>
                   <a:srgbClr val="FFFFFF"/>
                 </a:solidFill>
@@ -8173,8 +8504,8 @@
         </p:nvSpPr>
         <p:spPr>
           <a:xfrm>
-            <a:off x="685800" y="960120"/>
-            <a:ext cx="5257800" cy="411480"/>
+            <a:off x="685800" y="914400"/>
+            <a:ext cx="5212080" cy="320040"/>
           </a:xfrm>
           <a:prstGeom prst="rect">
             <a:avLst/>
@@ -8182,14 +8513,14 @@
           <a:noFill/>
         </p:spPr>
         <p:txBody>
-          <a:bodyPr wrap="square">
+          <a:bodyPr wrap="square" anchor="t">
             <a:normAutofit/>
           </a:bodyPr>
           <a:lstStyle/>
           <a:p>
             <a:pPr algn="l"/>
             <a:r>
-              <a:rPr sz="2400" b="1">
+              <a:rPr sz="2300" b="1">
                 <a:solidFill>
                   <a:srgbClr val="0A1F44"/>
                 </a:solidFill>
@@ -8208,8 +8539,8 @@
         </p:nvSpPr>
         <p:spPr>
           <a:xfrm>
-            <a:off x="731520" y="1508760"/>
-            <a:ext cx="5166360" cy="4343400"/>
+            <a:off x="731520" y="1417320"/>
+            <a:ext cx="5166360" cy="4251960"/>
           </a:xfrm>
           <a:prstGeom prst="rect">
             <a:avLst/>
@@ -8217,16 +8548,16 @@
           <a:noFill/>
         </p:spPr>
         <p:txBody>
-          <a:bodyPr wrap="square" lIns="45720" rIns="45720">
-            <a:spAutoFit/>
+          <a:bodyPr wrap="square" lIns="73152" rIns="73152" tIns="18288">
+            <a:normAutofit/>
           </a:bodyPr>
           <a:lstStyle/>
           <a:p>
             <a:pPr>
               <a:spcAft>
-                <a:spcPts val="800"/>
+                <a:spcPts val="500"/>
               </a:spcAft>
-              <a:defRPr sz="1700">
+              <a:defRPr sz="1600">
                 <a:solidFill>
                   <a:srgbClr val="232D3C"/>
                 </a:solidFill>
@@ -8234,15 +8565,15 @@
               </a:defRPr>
             </a:pPr>
             <a:r>
-              <a:t>Drift fuerte: test tiene generos/subgeneros que casi no aparecen en train.</a:t>
+              <a:t>Drift fuerte: test tiene géneros/subgéneros casi ausentes en train.</a:t>
             </a:r>
           </a:p>
           <a:p>
             <a:pPr>
               <a:spcAft>
-                <a:spcPts val="800"/>
+                <a:spcPts val="500"/>
               </a:spcAft>
-              <a:defRPr sz="1700">
+              <a:defRPr sz="1600">
                 <a:solidFill>
                   <a:srgbClr val="232D3C"/>
                 </a:solidFill>
@@ -8250,15 +8581,15 @@
               </a:defRPr>
             </a:pPr>
             <a:r>
-              <a:t>El leaderboard publico representa solo una parte del test; optimizarlo puede no generalizar al privado.</a:t>
+              <a:t>El leaderboard público representa solo una parte del test.</a:t>
             </a:r>
           </a:p>
           <a:p>
             <a:pPr>
               <a:spcAft>
-                <a:spcPts val="800"/>
+                <a:spcPts val="500"/>
               </a:spcAft>
-              <a:defRPr sz="1700">
+              <a:defRPr sz="1600">
                 <a:solidFill>
                   <a:srgbClr val="232D3C"/>
                 </a:solidFill>
@@ -8266,15 +8597,15 @@
               </a:defRPr>
             </a:pPr>
             <a:r>
-              <a:t>Los ajustes por subgenero son efectivos, pero dependen de hipotesis manuales.</a:t>
+              <a:t>Los ajustes por subgénero dependen de hipótesis manuales.</a:t>
             </a:r>
           </a:p>
           <a:p>
             <a:pPr>
               <a:spcAft>
-                <a:spcPts val="800"/>
+                <a:spcPts val="500"/>
               </a:spcAft>
-              <a:defRPr sz="1700">
+              <a:defRPr sz="1600">
                 <a:solidFill>
                   <a:srgbClr val="232D3C"/>
                 </a:solidFill>
@@ -8282,15 +8613,15 @@
               </a:defRPr>
             </a:pPr>
             <a:r>
-              <a:t>La validacion interna no replica completamente la distribucion real de Kaggle.</a:t>
+              <a:t>La validación interna no replica completamente Kaggle.</a:t>
             </a:r>
           </a:p>
           <a:p>
             <a:pPr>
               <a:spcAft>
-                <a:spcPts val="800"/>
+                <a:spcPts val="500"/>
               </a:spcAft>
-              <a:defRPr sz="1700">
+              <a:defRPr sz="1600">
                 <a:solidFill>
                   <a:srgbClr val="232D3C"/>
                 </a:solidFill>
@@ -8298,7 +8629,7 @@
               </a:defRPr>
             </a:pPr>
             <a:r>
-              <a:t>El solver de leaderboard no es un modelo generalizable a datos nuevos.</a:t>
+              <a:t>El solver de leaderboard no generaliza a datos nuevos.</a:t>
             </a:r>
           </a:p>
         </p:txBody>
@@ -8311,8 +8642,8 @@
         </p:nvSpPr>
         <p:spPr>
           <a:xfrm>
-            <a:off x="6400800" y="960120"/>
-            <a:ext cx="5029200" cy="411480"/>
+            <a:off x="6400800" y="914400"/>
+            <a:ext cx="5029200" cy="320040"/>
           </a:xfrm>
           <a:prstGeom prst="rect">
             <a:avLst/>
@@ -8320,20 +8651,20 @@
           <a:noFill/>
         </p:spPr>
         <p:txBody>
-          <a:bodyPr wrap="square">
+          <a:bodyPr wrap="square" anchor="t">
             <a:normAutofit/>
           </a:bodyPr>
           <a:lstStyle/>
           <a:p>
             <a:pPr algn="l"/>
             <a:r>
-              <a:rPr sz="2400" b="1">
+              <a:rPr sz="2300" b="1">
                 <a:solidFill>
                   <a:srgbClr val="0A1F44"/>
                 </a:solidFill>
                 <a:latin typeface="Aptos"/>
               </a:rPr>
-              <a:t>Mejoras con mas tiempo</a:t>
+              <a:t>Mejoras con más tiempo</a:t>
             </a:r>
           </a:p>
         </p:txBody>
@@ -8346,8 +8677,8 @@
         </p:nvSpPr>
         <p:spPr>
           <a:xfrm>
-            <a:off x="6446520" y="1508760"/>
-            <a:ext cx="4983480" cy="4343400"/>
+            <a:off x="6446520" y="1417320"/>
+            <a:ext cx="4983480" cy="4251960"/>
           </a:xfrm>
           <a:prstGeom prst="rect">
             <a:avLst/>
@@ -8355,16 +8686,16 @@
           <a:noFill/>
         </p:spPr>
         <p:txBody>
-          <a:bodyPr wrap="square" lIns="45720" rIns="45720">
-            <a:spAutoFit/>
+          <a:bodyPr wrap="square" lIns="73152" rIns="73152" tIns="18288">
+            <a:normAutofit/>
           </a:bodyPr>
           <a:lstStyle/>
           <a:p>
             <a:pPr>
               <a:spcAft>
-                <a:spcPts val="800"/>
+                <a:spcPts val="500"/>
               </a:spcAft>
-              <a:defRPr sz="1700">
+              <a:defRPr sz="1600">
                 <a:solidFill>
                   <a:srgbClr val="232D3C"/>
                 </a:solidFill>
@@ -8372,15 +8703,15 @@
               </a:defRPr>
             </a:pPr>
             <a:r>
-              <a:t>Diseniar una validacion que simule mejor el drift train/test.</a:t>
+              <a:t>Diseñar una validación que simule mejor el drift.</a:t>
             </a:r>
           </a:p>
           <a:p>
             <a:pPr>
               <a:spcAft>
-                <a:spcPts val="800"/>
+                <a:spcPts val="500"/>
               </a:spcAft>
-              <a:defRPr sz="1700">
+              <a:defRPr sz="1600">
                 <a:solidFill>
                   <a:srgbClr val="232D3C"/>
                 </a:solidFill>
@@ -8388,15 +8719,15 @@
               </a:defRPr>
             </a:pPr>
             <a:r>
-              <a:t>Buscar datos externos o features temporales/artista mas robustas.</a:t>
+              <a:t>Buscar datos externos o features de artista más robustas.</a:t>
             </a:r>
           </a:p>
           <a:p>
             <a:pPr>
               <a:spcAft>
-                <a:spcPts val="800"/>
+                <a:spcPts val="500"/>
               </a:spcAft>
-              <a:defRPr sz="1700">
+              <a:defRPr sz="1600">
                 <a:solidFill>
                   <a:srgbClr val="232D3C"/>
                 </a:solidFill>
@@ -8404,15 +8735,15 @@
               </a:defRPr>
             </a:pPr>
             <a:r>
-              <a:t>Entrenar modelos especializados por genero o subgenero.</a:t>
+              <a:t>Entrenar modelos especializados por género o subgénero.</a:t>
             </a:r>
           </a:p>
           <a:p>
             <a:pPr>
               <a:spcAft>
-                <a:spcPts val="800"/>
+                <a:spcPts val="500"/>
               </a:spcAft>
-              <a:defRPr sz="1700">
+              <a:defRPr sz="1600">
                 <a:solidFill>
                   <a:srgbClr val="232D3C"/>
                 </a:solidFill>
@@ -8420,15 +8751,15 @@
               </a:defRPr>
             </a:pPr>
             <a:r>
-              <a:t>Automatizar seleccion de reglas con validacion honesta.</a:t>
+              <a:t>Automatizar reglas con validación honesta.</a:t>
             </a:r>
           </a:p>
           <a:p>
             <a:pPr>
               <a:spcAft>
-                <a:spcPts val="800"/>
+                <a:spcPts val="500"/>
               </a:spcAft>
-              <a:defRPr sz="1700">
+              <a:defRPr sz="1600">
                 <a:solidFill>
                   <a:srgbClr val="232D3C"/>
                 </a:solidFill>
@@ -8436,7 +8767,7 @@
               </a:defRPr>
             </a:pPr>
             <a:r>
-              <a:t>Usar ensambles mas estables y menos dependientes del leaderboard publico.</a:t>
+              <a:t>Usar ensambles menos dependientes del leaderboard público.</a:t>
             </a:r>
           </a:p>
         </p:txBody>

</xml_diff>